<commit_message>
Final submission: update README, remove old presentation, clean workspace
</commit_message>
<xml_diff>
--- a/British_Airways_Premium_Presentation.pptx
+++ b/British_Airways_Premium_Presentation.pptx
@@ -4,21 +4,24 @@
   <p:sldMasterIdLst>
     <p:sldMasterId id="2147483648" r:id="rId1"/>
   </p:sldMasterIdLst>
+  <p:notesMasterIdLst>
+    <p:notesMasterId r:id="rId14"/>
+  </p:notesMasterIdLst>
   <p:sldIdLst>
-    <p:sldId id="256" r:id="rId7"/>
-    <p:sldId id="257" r:id="rId9"/>
-    <p:sldId id="258" r:id="rId10"/>
-    <p:sldId id="259" r:id="rId11"/>
-    <p:sldId id="260" r:id="rId12"/>
-    <p:sldId id="261" r:id="rId13"/>
-    <p:sldId id="262" r:id="rId14"/>
-    <p:sldId id="263" r:id="rId15"/>
-    <p:sldId id="264" r:id="rId16"/>
-    <p:sldId id="265" r:id="rId17"/>
-    <p:sldId id="266" r:id="rId18"/>
-    <p:sldId id="267" r:id="rId19"/>
+    <p:sldId id="256" r:id="rId2"/>
+    <p:sldId id="257" r:id="rId3"/>
+    <p:sldId id="258" r:id="rId4"/>
+    <p:sldId id="259" r:id="rId5"/>
+    <p:sldId id="260" r:id="rId6"/>
+    <p:sldId id="261" r:id="rId7"/>
+    <p:sldId id="262" r:id="rId8"/>
+    <p:sldId id="263" r:id="rId9"/>
+    <p:sldId id="264" r:id="rId10"/>
+    <p:sldId id="265" r:id="rId11"/>
+    <p:sldId id="266" r:id="rId12"/>
+    <p:sldId id="267" r:id="rId13"/>
   </p:sldIdLst>
-  <p:sldSz cx="12191695" cy="6858000" type="screen4x3"/>
+  <p:sldSz cx="12192000" cy="6858000"/>
   <p:notesSz cx="6858000" cy="9144000"/>
   <p:defaultTextStyle>
     <a:defPPr>
@@ -115,11 +118,27 @@
       </a:defRPr>
     </a:lvl9pPr>
   </p:defaultTextStyle>
+  <p:extLst>
+    <p:ext uri="{EFAFB233-063F-42B5-8137-9DF3F51BA10A}">
+      <p15:sldGuideLst xmlns:p15="http://schemas.microsoft.com/office/powerpoint/2012/main">
+        <p15:guide id="1" orient="horz" pos="2160">
+          <p15:clr>
+            <a:srgbClr val="A4A3A4"/>
+          </p15:clr>
+        </p15:guide>
+        <p15:guide id="2" pos="2880">
+          <p15:clr>
+            <a:srgbClr val="A4A3A4"/>
+          </p15:clr>
+        </p15:guide>
+      </p15:sldGuideLst>
+    </p:ext>
+  </p:extLst>
 </p:presentation>
 </file>
 
 <file path=ppt/notesMasters/notesMaster1.xml><?xml version="1.0" encoding="utf-8"?>
-<p:notesMaster xmlns:a="http://schemas.openxmlformats.org/drawingml/2006/main" xmlns:p="http://schemas.openxmlformats.org/presentationml/2006/main" xmlns:r="http://schemas.openxmlformats.org/officeDocument/2006/relationships">
+<p:notesMaster xmlns:a="http://schemas.openxmlformats.org/drawingml/2006/main" xmlns:r="http://schemas.openxmlformats.org/officeDocument/2006/relationships" xmlns:p="http://schemas.openxmlformats.org/presentationml/2006/main">
   <p:cSld>
     <p:bg>
       <p:bgRef idx="1001">
@@ -140,241 +159,16 @@
           <a:chExt cx="0" cy="0"/>
         </a:xfrm>
       </p:grpSpPr>
-      <p:sp>
-        <p:nvSpPr>
-          <p:cNvPr id="2" name="Header Placeholder 1"/>
-          <p:cNvSpPr>
-            <a:spLocks noGrp="1"/>
-          </p:cNvSpPr>
-          <p:nvPr>
-            <p:ph type="hdr" sz="quarter"/>
-          </p:nvPr>
-        </p:nvSpPr>
-        <p:spPr>
-          <a:xfrm>
-            <a:off x="0" y="0"/>
-            <a:ext cx="2971800" cy="457200"/>
-          </a:xfrm>
-          <a:prstGeom prst="rect">
-            <a:avLst/>
-          </a:prstGeom>
-        </p:spPr>
-        <p:txBody>
-          <a:bodyPr vert="horz" lIns="91440" tIns="45720" rIns="91440" bIns="45720" rtlCol="0"/>
-          <a:lstStyle>
-            <a:lvl1pPr algn="l">
-              <a:defRPr sz="1200"/>
-            </a:lvl1pPr>
-          </a:lstStyle>
-          <a:p>
-            <a:endParaRPr lang="en-US"/>
-          </a:p>
-        </p:txBody>
-      </p:sp>
-      <p:sp>
-        <p:nvSpPr>
-          <p:cNvPr id="3" name="Date Placeholder 2"/>
-          <p:cNvSpPr>
-            <a:spLocks noGrp="1"/>
-          </p:cNvSpPr>
-          <p:nvPr>
-            <p:ph type="dt" idx="1"/>
-          </p:nvPr>
-        </p:nvSpPr>
-        <p:spPr>
-          <a:xfrm>
-            <a:off x="3884613" y="0"/>
-            <a:ext cx="2971800" cy="457200"/>
-          </a:xfrm>
-          <a:prstGeom prst="rect">
-            <a:avLst/>
-          </a:prstGeom>
-        </p:spPr>
-        <p:txBody>
-          <a:bodyPr vert="horz" lIns="91440" tIns="45720" rIns="91440" bIns="45720" rtlCol="0"/>
-          <a:lstStyle>
-            <a:lvl1pPr algn="r">
-              <a:defRPr sz="1200"/>
-            </a:lvl1pPr>
-          </a:lstStyle>
-          <a:p>
-            <a:fld id="{0F89C1C7-3DCD-1040-A9CF-14679D8B5DDD}" type="datetimeFigureOut">
-              <a:rPr lang="en-US" smtClean="0"/>
-              <a:t>10/17/16</a:t>
-            </a:fld>
-            <a:endParaRPr lang="en-US"/>
-          </a:p>
-        </p:txBody>
-      </p:sp>
-      <p:sp>
-        <p:nvSpPr>
-          <p:cNvPr id="4" name="Slide Image Placeholder 3"/>
-          <p:cNvSpPr>
-            <a:spLocks noGrp="1" noRot="1" noChangeAspect="1"/>
-          </p:cNvSpPr>
-          <p:nvPr>
-            <p:ph type="sldImg" idx="2"/>
-          </p:nvPr>
-        </p:nvSpPr>
-        <p:spPr>
-          <a:xfrm>
-            <a:off x="1143000" y="685800"/>
-            <a:ext cx="4572000" cy="3429000"/>
-          </a:xfrm>
-          <a:prstGeom prst="rect">
-            <a:avLst/>
-          </a:prstGeom>
-          <a:noFill/>
-          <a:ln w="12700">
-            <a:solidFill>
-              <a:prstClr val="black"/>
-            </a:solidFill>
-          </a:ln>
-        </p:spPr>
-        <p:txBody>
-          <a:bodyPr vert="horz" lIns="91440" tIns="45720" rIns="91440" bIns="45720" rtlCol="0" anchor="ctr"/>
-          <a:lstStyle/>
-          <a:p>
-            <a:endParaRPr lang="en-US"/>
-          </a:p>
-        </p:txBody>
-      </p:sp>
-      <p:sp>
-        <p:nvSpPr>
-          <p:cNvPr id="5" name="Notes Placeholder 4"/>
-          <p:cNvSpPr>
-            <a:spLocks noGrp="1"/>
-          </p:cNvSpPr>
-          <p:nvPr>
-            <p:ph type="body" sz="quarter" idx="3"/>
-          </p:nvPr>
-        </p:nvSpPr>
-        <p:spPr>
-          <a:xfrm>
-            <a:off x="685800" y="4343400"/>
-            <a:ext cx="5486400" cy="4114800"/>
-          </a:xfrm>
-          <a:prstGeom prst="rect">
-            <a:avLst/>
-          </a:prstGeom>
-        </p:spPr>
-        <p:txBody>
-          <a:bodyPr vert="horz" lIns="91440" tIns="45720" rIns="91440" bIns="45720" rtlCol="0"/>
-          <a:lstStyle/>
-          <a:p>
-            <a:pPr lvl="0"/>
-            <a:r>
-              <a:rPr lang="en-US" smtClean="0"/>
-              <a:t>Click to edit Master text styles</a:t>
-            </a:r>
-          </a:p>
-          <a:p>
-            <a:pPr lvl="1"/>
-            <a:r>
-              <a:rPr lang="en-US" smtClean="0"/>
-              <a:t>Second level</a:t>
-            </a:r>
-          </a:p>
-          <a:p>
-            <a:pPr lvl="2"/>
-            <a:r>
-              <a:rPr lang="en-US" smtClean="0"/>
-              <a:t>Third level</a:t>
-            </a:r>
-          </a:p>
-          <a:p>
-            <a:pPr lvl="3"/>
-            <a:r>
-              <a:rPr lang="en-US" smtClean="0"/>
-              <a:t>Fourth level</a:t>
-            </a:r>
-          </a:p>
-          <a:p>
-            <a:pPr lvl="4"/>
-            <a:r>
-              <a:rPr lang="en-US" smtClean="0"/>
-              <a:t>Fifth level</a:t>
-            </a:r>
-            <a:endParaRPr lang="en-US"/>
-          </a:p>
-        </p:txBody>
-      </p:sp>
-      <p:sp>
-        <p:nvSpPr>
-          <p:cNvPr id="6" name="Footer Placeholder 5"/>
-          <p:cNvSpPr>
-            <a:spLocks noGrp="1"/>
-          </p:cNvSpPr>
-          <p:nvPr>
-            <p:ph type="ftr" sz="quarter" idx="4"/>
-          </p:nvPr>
-        </p:nvSpPr>
-        <p:spPr>
-          <a:xfrm>
-            <a:off x="0" y="8685213"/>
-            <a:ext cx="2971800" cy="457200"/>
-          </a:xfrm>
-          <a:prstGeom prst="rect">
-            <a:avLst/>
-          </a:prstGeom>
-        </p:spPr>
-        <p:txBody>
-          <a:bodyPr vert="horz" lIns="91440" tIns="45720" rIns="91440" bIns="45720" rtlCol="0" anchor="b"/>
-          <a:lstStyle>
-            <a:lvl1pPr algn="l">
-              <a:defRPr sz="1200"/>
-            </a:lvl1pPr>
-          </a:lstStyle>
-          <a:p>
-            <a:endParaRPr lang="en-US"/>
-          </a:p>
-        </p:txBody>
-      </p:sp>
-      <p:sp>
-        <p:nvSpPr>
-          <p:cNvPr id="7" name="Slide Number Placeholder 6"/>
-          <p:cNvSpPr>
-            <a:spLocks noGrp="1"/>
-          </p:cNvSpPr>
-          <p:nvPr>
-            <p:ph type="sldNum" sz="quarter" idx="5"/>
-          </p:nvPr>
-        </p:nvSpPr>
-        <p:spPr>
-          <a:xfrm>
-            <a:off x="3884613" y="8685213"/>
-            <a:ext cx="2971800" cy="457200"/>
-          </a:xfrm>
-          <a:prstGeom prst="rect">
-            <a:avLst/>
-          </a:prstGeom>
-        </p:spPr>
-        <p:txBody>
-          <a:bodyPr vert="horz" lIns="91440" tIns="45720" rIns="91440" bIns="45720" rtlCol="0" anchor="b"/>
-          <a:lstStyle>
-            <a:lvl1pPr algn="r">
-              <a:defRPr sz="1200"/>
-            </a:lvl1pPr>
-          </a:lstStyle>
-          <a:p>
-            <a:fld id="{BB5E49A5-4136-284D-997B-48E1D791AD67}" type="slidenum">
-              <a:rPr lang="en-US" smtClean="0"/>
-              <a:t>‹#›</a:t>
-            </a:fld>
-            <a:endParaRPr lang="en-US"/>
-          </a:p>
-        </p:txBody>
-      </p:sp>
     </p:spTree>
     <p:extLst>
       <p:ext uri="{BB962C8B-B14F-4D97-AF65-F5344CB8AC3E}">
-        <p14:creationId xmlns:p14="http://schemas.microsoft.com/office/powerpoint/2010/main" val="2623252185"/>
+        <p14:creationId xmlns:p14="http://schemas.microsoft.com/office/powerpoint/2010/main" val="3236115830"/>
       </p:ext>
     </p:extLst>
   </p:cSld>
   <p:clrMap bg1="lt1" tx1="dk1" bg2="lt2" tx2="dk2" accent1="accent1" accent2="accent2" accent3="accent3" accent4="accent4" accent5="accent5" accent6="accent6" hlink="hlink" folHlink="folHlink"/>
   <p:notesStyle>
-    <a:lvl1pPr marL="0" algn="l" defTabSz="457200" rtl="0" eaLnBrk="1" latinLnBrk="0" hangingPunct="1">
+    <a:lvl1pPr marL="0" algn="l" defTabSz="914400" rtl="0" eaLnBrk="1" latinLnBrk="0" hangingPunct="1">
       <a:defRPr sz="1200" kern="1200">
         <a:solidFill>
           <a:schemeClr val="tx1"/>
@@ -384,7 +178,7 @@
         <a:cs typeface="+mn-cs"/>
       </a:defRPr>
     </a:lvl1pPr>
-    <a:lvl2pPr marL="457200" algn="l" defTabSz="457200" rtl="0" eaLnBrk="1" latinLnBrk="0" hangingPunct="1">
+    <a:lvl2pPr marL="457200" algn="l" defTabSz="914400" rtl="0" eaLnBrk="1" latinLnBrk="0" hangingPunct="1">
       <a:defRPr sz="1200" kern="1200">
         <a:solidFill>
           <a:schemeClr val="tx1"/>
@@ -394,7 +188,7 @@
         <a:cs typeface="+mn-cs"/>
       </a:defRPr>
     </a:lvl2pPr>
-    <a:lvl3pPr marL="914400" algn="l" defTabSz="457200" rtl="0" eaLnBrk="1" latinLnBrk="0" hangingPunct="1">
+    <a:lvl3pPr marL="914400" algn="l" defTabSz="914400" rtl="0" eaLnBrk="1" latinLnBrk="0" hangingPunct="1">
       <a:defRPr sz="1200" kern="1200">
         <a:solidFill>
           <a:schemeClr val="tx1"/>
@@ -404,7 +198,7 @@
         <a:cs typeface="+mn-cs"/>
       </a:defRPr>
     </a:lvl3pPr>
-    <a:lvl4pPr marL="1371600" algn="l" defTabSz="457200" rtl="0" eaLnBrk="1" latinLnBrk="0" hangingPunct="1">
+    <a:lvl4pPr marL="1371600" algn="l" defTabSz="914400" rtl="0" eaLnBrk="1" latinLnBrk="0" hangingPunct="1">
       <a:defRPr sz="1200" kern="1200">
         <a:solidFill>
           <a:schemeClr val="tx1"/>
@@ -414,7 +208,7 @@
         <a:cs typeface="+mn-cs"/>
       </a:defRPr>
     </a:lvl4pPr>
-    <a:lvl5pPr marL="1828800" algn="l" defTabSz="457200" rtl="0" eaLnBrk="1" latinLnBrk="0" hangingPunct="1">
+    <a:lvl5pPr marL="1828800" algn="l" defTabSz="914400" rtl="0" eaLnBrk="1" latinLnBrk="0" hangingPunct="1">
       <a:defRPr sz="1200" kern="1200">
         <a:solidFill>
           <a:schemeClr val="tx1"/>
@@ -424,7 +218,7 @@
         <a:cs typeface="+mn-cs"/>
       </a:defRPr>
     </a:lvl5pPr>
-    <a:lvl6pPr marL="2286000" algn="l" defTabSz="457200" rtl="0" eaLnBrk="1" latinLnBrk="0" hangingPunct="1">
+    <a:lvl6pPr marL="2286000" algn="l" defTabSz="914400" rtl="0" eaLnBrk="1" latinLnBrk="0" hangingPunct="1">
       <a:defRPr sz="1200" kern="1200">
         <a:solidFill>
           <a:schemeClr val="tx1"/>
@@ -434,7 +228,7 @@
         <a:cs typeface="+mn-cs"/>
       </a:defRPr>
     </a:lvl6pPr>
-    <a:lvl7pPr marL="2743200" algn="l" defTabSz="457200" rtl="0" eaLnBrk="1" latinLnBrk="0" hangingPunct="1">
+    <a:lvl7pPr marL="2743200" algn="l" defTabSz="914400" rtl="0" eaLnBrk="1" latinLnBrk="0" hangingPunct="1">
       <a:defRPr sz="1200" kern="1200">
         <a:solidFill>
           <a:schemeClr val="tx1"/>
@@ -444,7 +238,7 @@
         <a:cs typeface="+mn-cs"/>
       </a:defRPr>
     </a:lvl7pPr>
-    <a:lvl8pPr marL="3200400" algn="l" defTabSz="457200" rtl="0" eaLnBrk="1" latinLnBrk="0" hangingPunct="1">
+    <a:lvl8pPr marL="3200400" algn="l" defTabSz="914400" rtl="0" eaLnBrk="1" latinLnBrk="0" hangingPunct="1">
       <a:defRPr sz="1200" kern="1200">
         <a:solidFill>
           <a:schemeClr val="tx1"/>
@@ -454,7 +248,7 @@
         <a:cs typeface="+mn-cs"/>
       </a:defRPr>
     </a:lvl8pPr>
-    <a:lvl9pPr marL="3657600" algn="l" defTabSz="457200" rtl="0" eaLnBrk="1" latinLnBrk="0" hangingPunct="1">
+    <a:lvl9pPr marL="3657600" algn="l" defTabSz="914400" rtl="0" eaLnBrk="1" latinLnBrk="0" hangingPunct="1">
       <a:defRPr sz="1200" kern="1200">
         <a:solidFill>
           <a:schemeClr val="tx1"/>
@@ -469,7 +263,7 @@
 </file>
 
 <file path=ppt/notesSlides/notesSlide1.xml><?xml version="1.0" encoding="utf-8"?>
-<p:notes xmlns:a="http://schemas.openxmlformats.org/drawingml/2006/main" xmlns:p="http://schemas.openxmlformats.org/presentationml/2006/main" xmlns:r="http://schemas.openxmlformats.org/officeDocument/2006/relationships">
+<p:notes xmlns:a="http://schemas.openxmlformats.org/drawingml/2006/main" xmlns:r="http://schemas.openxmlformats.org/officeDocument/2006/relationships" xmlns:p="http://schemas.openxmlformats.org/presentationml/2006/main">
   <p:cSld>
     <p:spTree>
       <p:nvGrpSpPr>
@@ -489,7 +283,7 @@
         <p:nvSpPr>
           <p:cNvPr id="2" name="Slide Image Placeholder 1"/>
           <p:cNvSpPr>
-            <a:spLocks noGrp="1"/>
+            <a:spLocks noGrp="1" noRot="1" noChangeAspect="1"/>
           </p:cNvSpPr>
           <p:nvPr>
             <p:ph type="sldImg" idx="2"/>
@@ -504,7 +298,7 @@
             <a:spLocks noGrp="1"/>
           </p:cNvSpPr>
           <p:nvPr>
-            <p:ph type="body" idx="3" sz="quarter"/>
+            <p:ph type="body" sz="quarter" idx="3"/>
           </p:nvPr>
         </p:nvSpPr>
         <p:spPr/>
@@ -525,7 +319,7 @@
             <a:spLocks noGrp="1"/>
           </p:cNvSpPr>
           <p:nvPr>
-            <p:ph type="sldNum" idx="5" sz="quarter"/>
+            <p:ph type="sldNum" sz="quarter" idx="5"/>
           </p:nvPr>
         </p:nvSpPr>
         <p:spPr/>
@@ -539,7 +333,7 @@
 </file>
 
 <file path=ppt/notesSlides/notesSlide10.xml><?xml version="1.0" encoding="utf-8"?>
-<p:notes xmlns:a="http://schemas.openxmlformats.org/drawingml/2006/main" xmlns:p="http://schemas.openxmlformats.org/presentationml/2006/main" xmlns:r="http://schemas.openxmlformats.org/officeDocument/2006/relationships">
+<p:notes xmlns:a="http://schemas.openxmlformats.org/drawingml/2006/main" xmlns:r="http://schemas.openxmlformats.org/officeDocument/2006/relationships" xmlns:p="http://schemas.openxmlformats.org/presentationml/2006/main">
   <p:cSld>
     <p:spTree>
       <p:nvGrpSpPr>
@@ -559,7 +353,7 @@
         <p:nvSpPr>
           <p:cNvPr id="2" name="Slide Image Placeholder 1"/>
           <p:cNvSpPr>
-            <a:spLocks noGrp="1"/>
+            <a:spLocks noGrp="1" noRot="1" noChangeAspect="1"/>
           </p:cNvSpPr>
           <p:nvPr>
             <p:ph type="sldImg" idx="2"/>
@@ -574,7 +368,7 @@
             <a:spLocks noGrp="1"/>
           </p:cNvSpPr>
           <p:nvPr>
-            <p:ph type="body" idx="3" sz="quarter"/>
+            <p:ph type="body" sz="quarter" idx="3"/>
           </p:nvPr>
         </p:nvSpPr>
         <p:spPr/>
@@ -595,7 +389,7 @@
             <a:spLocks noGrp="1"/>
           </p:cNvSpPr>
           <p:nvPr>
-            <p:ph type="sldNum" idx="5" sz="quarter"/>
+            <p:ph type="sldNum" sz="quarter" idx="5"/>
           </p:nvPr>
         </p:nvSpPr>
         <p:spPr/>
@@ -609,7 +403,7 @@
 </file>
 
 <file path=ppt/notesSlides/notesSlide11.xml><?xml version="1.0" encoding="utf-8"?>
-<p:notes xmlns:a="http://schemas.openxmlformats.org/drawingml/2006/main" xmlns:p="http://schemas.openxmlformats.org/presentationml/2006/main" xmlns:r="http://schemas.openxmlformats.org/officeDocument/2006/relationships">
+<p:notes xmlns:a="http://schemas.openxmlformats.org/drawingml/2006/main" xmlns:r="http://schemas.openxmlformats.org/officeDocument/2006/relationships" xmlns:p="http://schemas.openxmlformats.org/presentationml/2006/main">
   <p:cSld>
     <p:spTree>
       <p:nvGrpSpPr>
@@ -629,7 +423,7 @@
         <p:nvSpPr>
           <p:cNvPr id="2" name="Slide Image Placeholder 1"/>
           <p:cNvSpPr>
-            <a:spLocks noGrp="1"/>
+            <a:spLocks noGrp="1" noRot="1" noChangeAspect="1"/>
           </p:cNvSpPr>
           <p:nvPr>
             <p:ph type="sldImg" idx="2"/>
@@ -644,7 +438,7 @@
             <a:spLocks noGrp="1"/>
           </p:cNvSpPr>
           <p:nvPr>
-            <p:ph type="body" idx="3" sz="quarter"/>
+            <p:ph type="body" sz="quarter" idx="3"/>
           </p:nvPr>
         </p:nvSpPr>
         <p:spPr/>
@@ -665,7 +459,7 @@
             <a:spLocks noGrp="1"/>
           </p:cNvSpPr>
           <p:nvPr>
-            <p:ph type="sldNum" idx="5" sz="quarter"/>
+            <p:ph type="sldNum" sz="quarter" idx="5"/>
           </p:nvPr>
         </p:nvSpPr>
         <p:spPr/>
@@ -679,7 +473,7 @@
 </file>
 
 <file path=ppt/notesSlides/notesSlide12.xml><?xml version="1.0" encoding="utf-8"?>
-<p:notes xmlns:a="http://schemas.openxmlformats.org/drawingml/2006/main" xmlns:p="http://schemas.openxmlformats.org/presentationml/2006/main" xmlns:r="http://schemas.openxmlformats.org/officeDocument/2006/relationships">
+<p:notes xmlns:a="http://schemas.openxmlformats.org/drawingml/2006/main" xmlns:r="http://schemas.openxmlformats.org/officeDocument/2006/relationships" xmlns:p="http://schemas.openxmlformats.org/presentationml/2006/main">
   <p:cSld>
     <p:spTree>
       <p:nvGrpSpPr>
@@ -699,7 +493,7 @@
         <p:nvSpPr>
           <p:cNvPr id="2" name="Slide Image Placeholder 1"/>
           <p:cNvSpPr>
-            <a:spLocks noGrp="1"/>
+            <a:spLocks noGrp="1" noRot="1" noChangeAspect="1"/>
           </p:cNvSpPr>
           <p:nvPr>
             <p:ph type="sldImg" idx="2"/>
@@ -714,7 +508,7 @@
             <a:spLocks noGrp="1"/>
           </p:cNvSpPr>
           <p:nvPr>
-            <p:ph type="body" idx="3" sz="quarter"/>
+            <p:ph type="body" sz="quarter" idx="3"/>
           </p:nvPr>
         </p:nvSpPr>
         <p:spPr/>
@@ -735,7 +529,7 @@
             <a:spLocks noGrp="1"/>
           </p:cNvSpPr>
           <p:nvPr>
-            <p:ph type="sldNum" idx="5" sz="quarter"/>
+            <p:ph type="sldNum" sz="quarter" idx="5"/>
           </p:nvPr>
         </p:nvSpPr>
         <p:spPr/>
@@ -749,7 +543,7 @@
 </file>
 
 <file path=ppt/notesSlides/notesSlide2.xml><?xml version="1.0" encoding="utf-8"?>
-<p:notes xmlns:a="http://schemas.openxmlformats.org/drawingml/2006/main" xmlns:p="http://schemas.openxmlformats.org/presentationml/2006/main" xmlns:r="http://schemas.openxmlformats.org/officeDocument/2006/relationships">
+<p:notes xmlns:a="http://schemas.openxmlformats.org/drawingml/2006/main" xmlns:r="http://schemas.openxmlformats.org/officeDocument/2006/relationships" xmlns:p="http://schemas.openxmlformats.org/presentationml/2006/main">
   <p:cSld>
     <p:spTree>
       <p:nvGrpSpPr>
@@ -769,7 +563,7 @@
         <p:nvSpPr>
           <p:cNvPr id="2" name="Slide Image Placeholder 1"/>
           <p:cNvSpPr>
-            <a:spLocks noGrp="1"/>
+            <a:spLocks noGrp="1" noRot="1" noChangeAspect="1"/>
           </p:cNvSpPr>
           <p:nvPr>
             <p:ph type="sldImg" idx="2"/>
@@ -784,7 +578,7 @@
             <a:spLocks noGrp="1"/>
           </p:cNvSpPr>
           <p:nvPr>
-            <p:ph type="body" idx="3" sz="quarter"/>
+            <p:ph type="body" sz="quarter" idx="3"/>
           </p:nvPr>
         </p:nvSpPr>
         <p:spPr/>
@@ -805,7 +599,7 @@
             <a:spLocks noGrp="1"/>
           </p:cNvSpPr>
           <p:nvPr>
-            <p:ph type="sldNum" idx="5" sz="quarter"/>
+            <p:ph type="sldNum" sz="quarter" idx="5"/>
           </p:nvPr>
         </p:nvSpPr>
         <p:spPr/>
@@ -819,7 +613,7 @@
 </file>
 
 <file path=ppt/notesSlides/notesSlide3.xml><?xml version="1.0" encoding="utf-8"?>
-<p:notes xmlns:a="http://schemas.openxmlformats.org/drawingml/2006/main" xmlns:p="http://schemas.openxmlformats.org/presentationml/2006/main" xmlns:r="http://schemas.openxmlformats.org/officeDocument/2006/relationships">
+<p:notes xmlns:a="http://schemas.openxmlformats.org/drawingml/2006/main" xmlns:r="http://schemas.openxmlformats.org/officeDocument/2006/relationships" xmlns:p="http://schemas.openxmlformats.org/presentationml/2006/main">
   <p:cSld>
     <p:spTree>
       <p:nvGrpSpPr>
@@ -839,7 +633,7 @@
         <p:nvSpPr>
           <p:cNvPr id="2" name="Slide Image Placeholder 1"/>
           <p:cNvSpPr>
-            <a:spLocks noGrp="1"/>
+            <a:spLocks noGrp="1" noRot="1" noChangeAspect="1"/>
           </p:cNvSpPr>
           <p:nvPr>
             <p:ph type="sldImg" idx="2"/>
@@ -854,7 +648,7 @@
             <a:spLocks noGrp="1"/>
           </p:cNvSpPr>
           <p:nvPr>
-            <p:ph type="body" idx="3" sz="quarter"/>
+            <p:ph type="body" sz="quarter" idx="3"/>
           </p:nvPr>
         </p:nvSpPr>
         <p:spPr/>
@@ -875,7 +669,7 @@
             <a:spLocks noGrp="1"/>
           </p:cNvSpPr>
           <p:nvPr>
-            <p:ph type="sldNum" idx="5" sz="quarter"/>
+            <p:ph type="sldNum" sz="quarter" idx="5"/>
           </p:nvPr>
         </p:nvSpPr>
         <p:spPr/>
@@ -889,7 +683,7 @@
 </file>
 
 <file path=ppt/notesSlides/notesSlide4.xml><?xml version="1.0" encoding="utf-8"?>
-<p:notes xmlns:a="http://schemas.openxmlformats.org/drawingml/2006/main" xmlns:p="http://schemas.openxmlformats.org/presentationml/2006/main" xmlns:r="http://schemas.openxmlformats.org/officeDocument/2006/relationships">
+<p:notes xmlns:a="http://schemas.openxmlformats.org/drawingml/2006/main" xmlns:r="http://schemas.openxmlformats.org/officeDocument/2006/relationships" xmlns:p="http://schemas.openxmlformats.org/presentationml/2006/main">
   <p:cSld>
     <p:spTree>
       <p:nvGrpSpPr>
@@ -909,7 +703,7 @@
         <p:nvSpPr>
           <p:cNvPr id="2" name="Slide Image Placeholder 1"/>
           <p:cNvSpPr>
-            <a:spLocks noGrp="1"/>
+            <a:spLocks noGrp="1" noRot="1" noChangeAspect="1"/>
           </p:cNvSpPr>
           <p:nvPr>
             <p:ph type="sldImg" idx="2"/>
@@ -924,7 +718,7 @@
             <a:spLocks noGrp="1"/>
           </p:cNvSpPr>
           <p:nvPr>
-            <p:ph type="body" idx="3" sz="quarter"/>
+            <p:ph type="body" sz="quarter" idx="3"/>
           </p:nvPr>
         </p:nvSpPr>
         <p:spPr/>
@@ -945,7 +739,7 @@
             <a:spLocks noGrp="1"/>
           </p:cNvSpPr>
           <p:nvPr>
-            <p:ph type="sldNum" idx="5" sz="quarter"/>
+            <p:ph type="sldNum" sz="quarter" idx="5"/>
           </p:nvPr>
         </p:nvSpPr>
         <p:spPr/>
@@ -959,7 +753,7 @@
 </file>
 
 <file path=ppt/notesSlides/notesSlide5.xml><?xml version="1.0" encoding="utf-8"?>
-<p:notes xmlns:a="http://schemas.openxmlformats.org/drawingml/2006/main" xmlns:p="http://schemas.openxmlformats.org/presentationml/2006/main" xmlns:r="http://schemas.openxmlformats.org/officeDocument/2006/relationships">
+<p:notes xmlns:a="http://schemas.openxmlformats.org/drawingml/2006/main" xmlns:r="http://schemas.openxmlformats.org/officeDocument/2006/relationships" xmlns:p="http://schemas.openxmlformats.org/presentationml/2006/main">
   <p:cSld>
     <p:spTree>
       <p:nvGrpSpPr>
@@ -979,7 +773,7 @@
         <p:nvSpPr>
           <p:cNvPr id="2" name="Slide Image Placeholder 1"/>
           <p:cNvSpPr>
-            <a:spLocks noGrp="1"/>
+            <a:spLocks noGrp="1" noRot="1" noChangeAspect="1"/>
           </p:cNvSpPr>
           <p:nvPr>
             <p:ph type="sldImg" idx="2"/>
@@ -994,7 +788,7 @@
             <a:spLocks noGrp="1"/>
           </p:cNvSpPr>
           <p:nvPr>
-            <p:ph type="body" idx="3" sz="quarter"/>
+            <p:ph type="body" sz="quarter" idx="3"/>
           </p:nvPr>
         </p:nvSpPr>
         <p:spPr/>
@@ -1015,7 +809,7 @@
             <a:spLocks noGrp="1"/>
           </p:cNvSpPr>
           <p:nvPr>
-            <p:ph type="sldNum" idx="5" sz="quarter"/>
+            <p:ph type="sldNum" sz="quarter" idx="5"/>
           </p:nvPr>
         </p:nvSpPr>
         <p:spPr/>
@@ -1029,7 +823,7 @@
 </file>
 
 <file path=ppt/notesSlides/notesSlide6.xml><?xml version="1.0" encoding="utf-8"?>
-<p:notes xmlns:a="http://schemas.openxmlformats.org/drawingml/2006/main" xmlns:p="http://schemas.openxmlformats.org/presentationml/2006/main" xmlns:r="http://schemas.openxmlformats.org/officeDocument/2006/relationships">
+<p:notes xmlns:a="http://schemas.openxmlformats.org/drawingml/2006/main" xmlns:r="http://schemas.openxmlformats.org/officeDocument/2006/relationships" xmlns:p="http://schemas.openxmlformats.org/presentationml/2006/main">
   <p:cSld>
     <p:spTree>
       <p:nvGrpSpPr>
@@ -1049,7 +843,7 @@
         <p:nvSpPr>
           <p:cNvPr id="2" name="Slide Image Placeholder 1"/>
           <p:cNvSpPr>
-            <a:spLocks noGrp="1"/>
+            <a:spLocks noGrp="1" noRot="1" noChangeAspect="1"/>
           </p:cNvSpPr>
           <p:nvPr>
             <p:ph type="sldImg" idx="2"/>
@@ -1064,7 +858,7 @@
             <a:spLocks noGrp="1"/>
           </p:cNvSpPr>
           <p:nvPr>
-            <p:ph type="body" idx="3" sz="quarter"/>
+            <p:ph type="body" sz="quarter" idx="3"/>
           </p:nvPr>
         </p:nvSpPr>
         <p:spPr/>
@@ -1085,7 +879,7 @@
             <a:spLocks noGrp="1"/>
           </p:cNvSpPr>
           <p:nvPr>
-            <p:ph type="sldNum" idx="5" sz="quarter"/>
+            <p:ph type="sldNum" sz="quarter" idx="5"/>
           </p:nvPr>
         </p:nvSpPr>
         <p:spPr/>
@@ -1099,7 +893,7 @@
 </file>
 
 <file path=ppt/notesSlides/notesSlide7.xml><?xml version="1.0" encoding="utf-8"?>
-<p:notes xmlns:a="http://schemas.openxmlformats.org/drawingml/2006/main" xmlns:p="http://schemas.openxmlformats.org/presentationml/2006/main" xmlns:r="http://schemas.openxmlformats.org/officeDocument/2006/relationships">
+<p:notes xmlns:a="http://schemas.openxmlformats.org/drawingml/2006/main" xmlns:r="http://schemas.openxmlformats.org/officeDocument/2006/relationships" xmlns:p="http://schemas.openxmlformats.org/presentationml/2006/main">
   <p:cSld>
     <p:spTree>
       <p:nvGrpSpPr>
@@ -1119,7 +913,7 @@
         <p:nvSpPr>
           <p:cNvPr id="2" name="Slide Image Placeholder 1"/>
           <p:cNvSpPr>
-            <a:spLocks noGrp="1"/>
+            <a:spLocks noGrp="1" noRot="1" noChangeAspect="1"/>
           </p:cNvSpPr>
           <p:nvPr>
             <p:ph type="sldImg" idx="2"/>
@@ -1134,7 +928,7 @@
             <a:spLocks noGrp="1"/>
           </p:cNvSpPr>
           <p:nvPr>
-            <p:ph type="body" idx="3" sz="quarter"/>
+            <p:ph type="body" sz="quarter" idx="3"/>
           </p:nvPr>
         </p:nvSpPr>
         <p:spPr/>
@@ -1155,7 +949,7 @@
             <a:spLocks noGrp="1"/>
           </p:cNvSpPr>
           <p:nvPr>
-            <p:ph type="sldNum" idx="5" sz="quarter"/>
+            <p:ph type="sldNum" sz="quarter" idx="5"/>
           </p:nvPr>
         </p:nvSpPr>
         <p:spPr/>
@@ -1169,7 +963,7 @@
 </file>
 
 <file path=ppt/notesSlides/notesSlide8.xml><?xml version="1.0" encoding="utf-8"?>
-<p:notes xmlns:a="http://schemas.openxmlformats.org/drawingml/2006/main" xmlns:p="http://schemas.openxmlformats.org/presentationml/2006/main" xmlns:r="http://schemas.openxmlformats.org/officeDocument/2006/relationships">
+<p:notes xmlns:a="http://schemas.openxmlformats.org/drawingml/2006/main" xmlns:r="http://schemas.openxmlformats.org/officeDocument/2006/relationships" xmlns:p="http://schemas.openxmlformats.org/presentationml/2006/main">
   <p:cSld>
     <p:spTree>
       <p:nvGrpSpPr>
@@ -1189,7 +983,7 @@
         <p:nvSpPr>
           <p:cNvPr id="2" name="Slide Image Placeholder 1"/>
           <p:cNvSpPr>
-            <a:spLocks noGrp="1"/>
+            <a:spLocks noGrp="1" noRot="1" noChangeAspect="1"/>
           </p:cNvSpPr>
           <p:nvPr>
             <p:ph type="sldImg" idx="2"/>
@@ -1204,7 +998,7 @@
             <a:spLocks noGrp="1"/>
           </p:cNvSpPr>
           <p:nvPr>
-            <p:ph type="body" idx="3" sz="quarter"/>
+            <p:ph type="body" sz="quarter" idx="3"/>
           </p:nvPr>
         </p:nvSpPr>
         <p:spPr/>
@@ -1225,7 +1019,7 @@
             <a:spLocks noGrp="1"/>
           </p:cNvSpPr>
           <p:nvPr>
-            <p:ph type="sldNum" idx="5" sz="quarter"/>
+            <p:ph type="sldNum" sz="quarter" idx="5"/>
           </p:nvPr>
         </p:nvSpPr>
         <p:spPr/>
@@ -1239,7 +1033,7 @@
 </file>
 
 <file path=ppt/notesSlides/notesSlide9.xml><?xml version="1.0" encoding="utf-8"?>
-<p:notes xmlns:a="http://schemas.openxmlformats.org/drawingml/2006/main" xmlns:p="http://schemas.openxmlformats.org/presentationml/2006/main" xmlns:r="http://schemas.openxmlformats.org/officeDocument/2006/relationships">
+<p:notes xmlns:a="http://schemas.openxmlformats.org/drawingml/2006/main" xmlns:r="http://schemas.openxmlformats.org/officeDocument/2006/relationships" xmlns:p="http://schemas.openxmlformats.org/presentationml/2006/main">
   <p:cSld>
     <p:spTree>
       <p:nvGrpSpPr>
@@ -1259,7 +1053,7 @@
         <p:nvSpPr>
           <p:cNvPr id="2" name="Slide Image Placeholder 1"/>
           <p:cNvSpPr>
-            <a:spLocks noGrp="1"/>
+            <a:spLocks noGrp="1" noRot="1" noChangeAspect="1"/>
           </p:cNvSpPr>
           <p:nvPr>
             <p:ph type="sldImg" idx="2"/>
@@ -1274,7 +1068,7 @@
             <a:spLocks noGrp="1"/>
           </p:cNvSpPr>
           <p:nvPr>
-            <p:ph type="body" idx="3" sz="quarter"/>
+            <p:ph type="body" sz="quarter" idx="3"/>
           </p:nvPr>
         </p:nvSpPr>
         <p:spPr/>
@@ -1295,7 +1089,7 @@
             <a:spLocks noGrp="1"/>
           </p:cNvSpPr>
           <p:nvPr>
-            <p:ph type="sldNum" idx="5" sz="quarter"/>
+            <p:ph type="sldNum" sz="quarter" idx="5"/>
           </p:nvPr>
         </p:nvSpPr>
         <p:spPr/>
@@ -1346,10 +1140,9 @@
           <a:lstStyle/>
           <a:p>
             <a:r>
-              <a:rPr lang="en-US" smtClean="0"/>
+              <a:rPr lang="en-US"/>
               <a:t>Click to edit Master title style</a:t>
             </a:r>
-            <a:endParaRPr lang="en-US"/>
           </a:p>
         </p:txBody>
       </p:sp>
@@ -1465,10 +1258,9 @@
           </a:lstStyle>
           <a:p>
             <a:r>
-              <a:rPr lang="en-US" smtClean="0"/>
+              <a:rPr lang="en-US"/>
               <a:t>Click to edit Master subtitle style</a:t>
             </a:r>
-            <a:endParaRPr lang="en-US"/>
           </a:p>
         </p:txBody>
       </p:sp>
@@ -1489,7 +1281,7 @@
           <a:p>
             <a:fld id="{5BCAD085-E8A6-8845-BD4E-CB4CCA059FC4}" type="datetimeFigureOut">
               <a:rPr lang="en-US" smtClean="0"/>
-              <a:t>1/27/13</a:t>
+              <a:t>6/24/2026</a:t>
             </a:fld>
             <a:endParaRPr lang="en-US"/>
           </a:p>
@@ -1583,10 +1375,9 @@
           <a:lstStyle/>
           <a:p>
             <a:r>
-              <a:rPr lang="en-US" smtClean="0"/>
+              <a:rPr lang="en-US"/>
               <a:t>Click to edit Master title style</a:t>
             </a:r>
-            <a:endParaRPr lang="en-US"/>
           </a:p>
         </p:txBody>
       </p:sp>
@@ -1607,38 +1398,37 @@
           <a:p>
             <a:pPr lvl="0"/>
             <a:r>
-              <a:rPr lang="en-US" smtClean="0"/>
+              <a:rPr lang="en-US"/>
               <a:t>Click to edit Master text styles</a:t>
             </a:r>
           </a:p>
           <a:p>
             <a:pPr lvl="1"/>
             <a:r>
-              <a:rPr lang="en-US" smtClean="0"/>
+              <a:rPr lang="en-US"/>
               <a:t>Second level</a:t>
             </a:r>
           </a:p>
           <a:p>
             <a:pPr lvl="2"/>
             <a:r>
-              <a:rPr lang="en-US" smtClean="0"/>
+              <a:rPr lang="en-US"/>
               <a:t>Third level</a:t>
             </a:r>
           </a:p>
           <a:p>
             <a:pPr lvl="3"/>
             <a:r>
-              <a:rPr lang="en-US" smtClean="0"/>
+              <a:rPr lang="en-US"/>
               <a:t>Fourth level</a:t>
             </a:r>
           </a:p>
           <a:p>
             <a:pPr lvl="4"/>
             <a:r>
-              <a:rPr lang="en-US" smtClean="0"/>
+              <a:rPr lang="en-US"/>
               <a:t>Fifth level</a:t>
             </a:r>
-            <a:endParaRPr lang="en-US"/>
           </a:p>
         </p:txBody>
       </p:sp>
@@ -1659,7 +1449,7 @@
           <a:p>
             <a:fld id="{5BCAD085-E8A6-8845-BD4E-CB4CCA059FC4}" type="datetimeFigureOut">
               <a:rPr lang="en-US" smtClean="0"/>
-              <a:t>1/27/13</a:t>
+              <a:t>6/24/2026</a:t>
             </a:fld>
             <a:endParaRPr lang="en-US"/>
           </a:p>
@@ -1758,10 +1548,9 @@
           <a:lstStyle/>
           <a:p>
             <a:r>
-              <a:rPr lang="en-US" smtClean="0"/>
+              <a:rPr lang="en-US"/>
               <a:t>Click to edit Master title style</a:t>
             </a:r>
-            <a:endParaRPr lang="en-US"/>
           </a:p>
         </p:txBody>
       </p:sp>
@@ -1787,38 +1576,37 @@
           <a:p>
             <a:pPr lvl="0"/>
             <a:r>
-              <a:rPr lang="en-US" smtClean="0"/>
+              <a:rPr lang="en-US"/>
               <a:t>Click to edit Master text styles</a:t>
             </a:r>
           </a:p>
           <a:p>
             <a:pPr lvl="1"/>
             <a:r>
-              <a:rPr lang="en-US" smtClean="0"/>
+              <a:rPr lang="en-US"/>
               <a:t>Second level</a:t>
             </a:r>
           </a:p>
           <a:p>
             <a:pPr lvl="2"/>
             <a:r>
-              <a:rPr lang="en-US" smtClean="0"/>
+              <a:rPr lang="en-US"/>
               <a:t>Third level</a:t>
             </a:r>
           </a:p>
           <a:p>
             <a:pPr lvl="3"/>
             <a:r>
-              <a:rPr lang="en-US" smtClean="0"/>
+              <a:rPr lang="en-US"/>
               <a:t>Fourth level</a:t>
             </a:r>
           </a:p>
           <a:p>
             <a:pPr lvl="4"/>
             <a:r>
-              <a:rPr lang="en-US" smtClean="0"/>
+              <a:rPr lang="en-US"/>
               <a:t>Fifth level</a:t>
             </a:r>
-            <a:endParaRPr lang="en-US"/>
           </a:p>
         </p:txBody>
       </p:sp>
@@ -1839,7 +1627,7 @@
           <a:p>
             <a:fld id="{5BCAD085-E8A6-8845-BD4E-CB4CCA059FC4}" type="datetimeFigureOut">
               <a:rPr lang="en-US" smtClean="0"/>
-              <a:t>1/27/13</a:t>
+              <a:t>6/24/2026</a:t>
             </a:fld>
             <a:endParaRPr lang="en-US"/>
           </a:p>
@@ -1933,10 +1721,9 @@
           <a:lstStyle/>
           <a:p>
             <a:r>
-              <a:rPr lang="en-US" smtClean="0"/>
+              <a:rPr lang="en-US"/>
               <a:t>Click to edit Master title style</a:t>
             </a:r>
-            <a:endParaRPr lang="en-US"/>
           </a:p>
         </p:txBody>
       </p:sp>
@@ -1957,38 +1744,37 @@
           <a:p>
             <a:pPr lvl="0"/>
             <a:r>
-              <a:rPr lang="en-US" smtClean="0"/>
+              <a:rPr lang="en-US"/>
               <a:t>Click to edit Master text styles</a:t>
             </a:r>
           </a:p>
           <a:p>
             <a:pPr lvl="1"/>
             <a:r>
-              <a:rPr lang="en-US" smtClean="0"/>
+              <a:rPr lang="en-US"/>
               <a:t>Second level</a:t>
             </a:r>
           </a:p>
           <a:p>
             <a:pPr lvl="2"/>
             <a:r>
-              <a:rPr lang="en-US" smtClean="0"/>
+              <a:rPr lang="en-US"/>
               <a:t>Third level</a:t>
             </a:r>
           </a:p>
           <a:p>
             <a:pPr lvl="3"/>
             <a:r>
-              <a:rPr lang="en-US" smtClean="0"/>
+              <a:rPr lang="en-US"/>
               <a:t>Fourth level</a:t>
             </a:r>
           </a:p>
           <a:p>
             <a:pPr lvl="4"/>
             <a:r>
-              <a:rPr lang="en-US" smtClean="0"/>
+              <a:rPr lang="en-US"/>
               <a:t>Fifth level</a:t>
             </a:r>
-            <a:endParaRPr lang="en-US"/>
           </a:p>
         </p:txBody>
       </p:sp>
@@ -2009,7 +1795,7 @@
           <a:p>
             <a:fld id="{5BCAD085-E8A6-8845-BD4E-CB4CCA059FC4}" type="datetimeFigureOut">
               <a:rPr lang="en-US" smtClean="0"/>
-              <a:t>1/27/13</a:t>
+              <a:t>6/24/2026</a:t>
             </a:fld>
             <a:endParaRPr lang="en-US"/>
           </a:p>
@@ -2112,10 +1898,9 @@
           </a:lstStyle>
           <a:p>
             <a:r>
-              <a:rPr lang="en-US" smtClean="0"/>
+              <a:rPr lang="en-US"/>
               <a:t>Click to edit Master title style</a:t>
             </a:r>
-            <a:endParaRPr lang="en-US"/>
           </a:p>
         </p:txBody>
       </p:sp>
@@ -2232,7 +2017,7 @@
           <a:p>
             <a:pPr lvl="0"/>
             <a:r>
-              <a:rPr lang="en-US" smtClean="0"/>
+              <a:rPr lang="en-US"/>
               <a:t>Click to edit Master text styles</a:t>
             </a:r>
           </a:p>
@@ -2255,7 +2040,7 @@
           <a:p>
             <a:fld id="{5BCAD085-E8A6-8845-BD4E-CB4CCA059FC4}" type="datetimeFigureOut">
               <a:rPr lang="en-US" smtClean="0"/>
-              <a:t>1/27/13</a:t>
+              <a:t>6/24/2026</a:t>
             </a:fld>
             <a:endParaRPr lang="en-US"/>
           </a:p>
@@ -2349,10 +2134,9 @@
           <a:lstStyle/>
           <a:p>
             <a:r>
-              <a:rPr lang="en-US" smtClean="0"/>
+              <a:rPr lang="en-US"/>
               <a:t>Click to edit Master title style</a:t>
             </a:r>
-            <a:endParaRPr lang="en-US"/>
           </a:p>
         </p:txBody>
       </p:sp>
@@ -2406,38 +2190,37 @@
           <a:p>
             <a:pPr lvl="0"/>
             <a:r>
-              <a:rPr lang="en-US" smtClean="0"/>
+              <a:rPr lang="en-US"/>
               <a:t>Click to edit Master text styles</a:t>
             </a:r>
           </a:p>
           <a:p>
             <a:pPr lvl="1"/>
             <a:r>
-              <a:rPr lang="en-US" smtClean="0"/>
+              <a:rPr lang="en-US"/>
               <a:t>Second level</a:t>
             </a:r>
           </a:p>
           <a:p>
             <a:pPr lvl="2"/>
             <a:r>
-              <a:rPr lang="en-US" smtClean="0"/>
+              <a:rPr lang="en-US"/>
               <a:t>Third level</a:t>
             </a:r>
           </a:p>
           <a:p>
             <a:pPr lvl="3"/>
             <a:r>
-              <a:rPr lang="en-US" smtClean="0"/>
+              <a:rPr lang="en-US"/>
               <a:t>Fourth level</a:t>
             </a:r>
           </a:p>
           <a:p>
             <a:pPr lvl="4"/>
             <a:r>
-              <a:rPr lang="en-US" smtClean="0"/>
+              <a:rPr lang="en-US"/>
               <a:t>Fifth level</a:t>
             </a:r>
-            <a:endParaRPr lang="en-US"/>
           </a:p>
         </p:txBody>
       </p:sp>
@@ -2491,38 +2274,37 @@
           <a:p>
             <a:pPr lvl="0"/>
             <a:r>
-              <a:rPr lang="en-US" smtClean="0"/>
+              <a:rPr lang="en-US"/>
               <a:t>Click to edit Master text styles</a:t>
             </a:r>
           </a:p>
           <a:p>
             <a:pPr lvl="1"/>
             <a:r>
-              <a:rPr lang="en-US" smtClean="0"/>
+              <a:rPr lang="en-US"/>
               <a:t>Second level</a:t>
             </a:r>
           </a:p>
           <a:p>
             <a:pPr lvl="2"/>
             <a:r>
-              <a:rPr lang="en-US" smtClean="0"/>
+              <a:rPr lang="en-US"/>
               <a:t>Third level</a:t>
             </a:r>
           </a:p>
           <a:p>
             <a:pPr lvl="3"/>
             <a:r>
-              <a:rPr lang="en-US" smtClean="0"/>
+              <a:rPr lang="en-US"/>
               <a:t>Fourth level</a:t>
             </a:r>
           </a:p>
           <a:p>
             <a:pPr lvl="4"/>
             <a:r>
-              <a:rPr lang="en-US" smtClean="0"/>
+              <a:rPr lang="en-US"/>
               <a:t>Fifth level</a:t>
             </a:r>
-            <a:endParaRPr lang="en-US"/>
           </a:p>
         </p:txBody>
       </p:sp>
@@ -2543,7 +2325,7 @@
           <a:p>
             <a:fld id="{5BCAD085-E8A6-8845-BD4E-CB4CCA059FC4}" type="datetimeFigureOut">
               <a:rPr lang="en-US" smtClean="0"/>
-              <a:t>1/27/13</a:t>
+              <a:t>6/24/2026</a:t>
             </a:fld>
             <a:endParaRPr lang="en-US"/>
           </a:p>
@@ -2641,10 +2423,9 @@
           </a:lstStyle>
           <a:p>
             <a:r>
-              <a:rPr lang="en-US" smtClean="0"/>
+              <a:rPr lang="en-US"/>
               <a:t>Click to edit Master title style</a:t>
             </a:r>
-            <a:endParaRPr lang="en-US"/>
           </a:p>
         </p:txBody>
       </p:sp>
@@ -2707,7 +2488,7 @@
           <a:p>
             <a:pPr lvl="0"/>
             <a:r>
-              <a:rPr lang="en-US" smtClean="0"/>
+              <a:rPr lang="en-US"/>
               <a:t>Click to edit Master text styles</a:t>
             </a:r>
           </a:p>
@@ -2763,38 +2544,37 @@
           <a:p>
             <a:pPr lvl="0"/>
             <a:r>
-              <a:rPr lang="en-US" smtClean="0"/>
+              <a:rPr lang="en-US"/>
               <a:t>Click to edit Master text styles</a:t>
             </a:r>
           </a:p>
           <a:p>
             <a:pPr lvl="1"/>
             <a:r>
-              <a:rPr lang="en-US" smtClean="0"/>
+              <a:rPr lang="en-US"/>
               <a:t>Second level</a:t>
             </a:r>
           </a:p>
           <a:p>
             <a:pPr lvl="2"/>
             <a:r>
-              <a:rPr lang="en-US" smtClean="0"/>
+              <a:rPr lang="en-US"/>
               <a:t>Third level</a:t>
             </a:r>
           </a:p>
           <a:p>
             <a:pPr lvl="3"/>
             <a:r>
-              <a:rPr lang="en-US" smtClean="0"/>
+              <a:rPr lang="en-US"/>
               <a:t>Fourth level</a:t>
             </a:r>
           </a:p>
           <a:p>
             <a:pPr lvl="4"/>
             <a:r>
-              <a:rPr lang="en-US" smtClean="0"/>
+              <a:rPr lang="en-US"/>
               <a:t>Fifth level</a:t>
             </a:r>
-            <a:endParaRPr lang="en-US"/>
           </a:p>
         </p:txBody>
       </p:sp>
@@ -2857,7 +2637,7 @@
           <a:p>
             <a:pPr lvl="0"/>
             <a:r>
-              <a:rPr lang="en-US" smtClean="0"/>
+              <a:rPr lang="en-US"/>
               <a:t>Click to edit Master text styles</a:t>
             </a:r>
           </a:p>
@@ -2913,38 +2693,37 @@
           <a:p>
             <a:pPr lvl="0"/>
             <a:r>
-              <a:rPr lang="en-US" smtClean="0"/>
+              <a:rPr lang="en-US"/>
               <a:t>Click to edit Master text styles</a:t>
             </a:r>
           </a:p>
           <a:p>
             <a:pPr lvl="1"/>
             <a:r>
-              <a:rPr lang="en-US" smtClean="0"/>
+              <a:rPr lang="en-US"/>
               <a:t>Second level</a:t>
             </a:r>
           </a:p>
           <a:p>
             <a:pPr lvl="2"/>
             <a:r>
-              <a:rPr lang="en-US" smtClean="0"/>
+              <a:rPr lang="en-US"/>
               <a:t>Third level</a:t>
             </a:r>
           </a:p>
           <a:p>
             <a:pPr lvl="3"/>
             <a:r>
-              <a:rPr lang="en-US" smtClean="0"/>
+              <a:rPr lang="en-US"/>
               <a:t>Fourth level</a:t>
             </a:r>
           </a:p>
           <a:p>
             <a:pPr lvl="4"/>
             <a:r>
-              <a:rPr lang="en-US" smtClean="0"/>
+              <a:rPr lang="en-US"/>
               <a:t>Fifth level</a:t>
             </a:r>
-            <a:endParaRPr lang="en-US"/>
           </a:p>
         </p:txBody>
       </p:sp>
@@ -2965,7 +2744,7 @@
           <a:p>
             <a:fld id="{5BCAD085-E8A6-8845-BD4E-CB4CCA059FC4}" type="datetimeFigureOut">
               <a:rPr lang="en-US" smtClean="0"/>
-              <a:t>1/27/13</a:t>
+              <a:t>6/24/2026</a:t>
             </a:fld>
             <a:endParaRPr lang="en-US"/>
           </a:p>
@@ -3059,10 +2838,9 @@
           <a:lstStyle/>
           <a:p>
             <a:r>
-              <a:rPr lang="en-US" smtClean="0"/>
+              <a:rPr lang="en-US"/>
               <a:t>Click to edit Master title style</a:t>
             </a:r>
-            <a:endParaRPr lang="en-US"/>
           </a:p>
         </p:txBody>
       </p:sp>
@@ -3083,7 +2861,7 @@
           <a:p>
             <a:fld id="{5BCAD085-E8A6-8845-BD4E-CB4CCA059FC4}" type="datetimeFigureOut">
               <a:rPr lang="en-US" smtClean="0"/>
-              <a:t>1/27/13</a:t>
+              <a:t>6/24/2026</a:t>
             </a:fld>
             <a:endParaRPr lang="en-US"/>
           </a:p>
@@ -3178,7 +2956,7 @@
           <a:p>
             <a:fld id="{5BCAD085-E8A6-8845-BD4E-CB4CCA059FC4}" type="datetimeFigureOut">
               <a:rPr lang="en-US" smtClean="0"/>
-              <a:t>1/27/13</a:t>
+              <a:t>6/24/2026</a:t>
             </a:fld>
             <a:endParaRPr lang="en-US"/>
           </a:p>
@@ -3281,10 +3059,9 @@
           </a:lstStyle>
           <a:p>
             <a:r>
-              <a:rPr lang="en-US" smtClean="0"/>
+              <a:rPr lang="en-US"/>
               <a:t>Click to edit Master title style</a:t>
             </a:r>
-            <a:endParaRPr lang="en-US"/>
           </a:p>
         </p:txBody>
       </p:sp>
@@ -3338,38 +3115,37 @@
           <a:p>
             <a:pPr lvl="0"/>
             <a:r>
-              <a:rPr lang="en-US" smtClean="0"/>
+              <a:rPr lang="en-US"/>
               <a:t>Click to edit Master text styles</a:t>
             </a:r>
           </a:p>
           <a:p>
             <a:pPr lvl="1"/>
             <a:r>
-              <a:rPr lang="en-US" smtClean="0"/>
+              <a:rPr lang="en-US"/>
               <a:t>Second level</a:t>
             </a:r>
           </a:p>
           <a:p>
             <a:pPr lvl="2"/>
             <a:r>
-              <a:rPr lang="en-US" smtClean="0"/>
+              <a:rPr lang="en-US"/>
               <a:t>Third level</a:t>
             </a:r>
           </a:p>
           <a:p>
             <a:pPr lvl="3"/>
             <a:r>
-              <a:rPr lang="en-US" smtClean="0"/>
+              <a:rPr lang="en-US"/>
               <a:t>Fourth level</a:t>
             </a:r>
           </a:p>
           <a:p>
             <a:pPr lvl="4"/>
             <a:r>
-              <a:rPr lang="en-US" smtClean="0"/>
+              <a:rPr lang="en-US"/>
               <a:t>Fifth level</a:t>
             </a:r>
-            <a:endParaRPr lang="en-US"/>
           </a:p>
         </p:txBody>
       </p:sp>
@@ -3432,7 +3208,7 @@
           <a:p>
             <a:pPr lvl="0"/>
             <a:r>
-              <a:rPr lang="en-US" smtClean="0"/>
+              <a:rPr lang="en-US"/>
               <a:t>Click to edit Master text styles</a:t>
             </a:r>
           </a:p>
@@ -3455,7 +3231,7 @@
           <a:p>
             <a:fld id="{5BCAD085-E8A6-8845-BD4E-CB4CCA059FC4}" type="datetimeFigureOut">
               <a:rPr lang="en-US" smtClean="0"/>
-              <a:t>1/27/13</a:t>
+              <a:t>6/24/2026</a:t>
             </a:fld>
             <a:endParaRPr lang="en-US"/>
           </a:p>
@@ -3558,10 +3334,9 @@
           </a:lstStyle>
           <a:p>
             <a:r>
-              <a:rPr lang="en-US" smtClean="0"/>
+              <a:rPr lang="en-US"/>
               <a:t>Click to edit Master title style</a:t>
             </a:r>
-            <a:endParaRPr lang="en-US"/>
           </a:p>
         </p:txBody>
       </p:sp>
@@ -3685,7 +3460,7 @@
           <a:p>
             <a:pPr lvl="0"/>
             <a:r>
-              <a:rPr lang="en-US" smtClean="0"/>
+              <a:rPr lang="en-US"/>
               <a:t>Click to edit Master text styles</a:t>
             </a:r>
           </a:p>
@@ -3708,7 +3483,7 @@
           <a:p>
             <a:fld id="{5BCAD085-E8A6-8845-BD4E-CB4CCA059FC4}" type="datetimeFigureOut">
               <a:rPr lang="en-US" smtClean="0"/>
-              <a:t>1/27/13</a:t>
+              <a:t>6/24/2026</a:t>
             </a:fld>
             <a:endParaRPr lang="en-US"/>
           </a:p>
@@ -3817,10 +3592,9 @@
           <a:lstStyle/>
           <a:p>
             <a:r>
-              <a:rPr lang="en-US" smtClean="0"/>
+              <a:rPr lang="en-US"/>
               <a:t>Click to edit Master title style</a:t>
             </a:r>
-            <a:endParaRPr lang="en-US"/>
           </a:p>
         </p:txBody>
       </p:sp>
@@ -3851,38 +3625,37 @@
           <a:p>
             <a:pPr lvl="0"/>
             <a:r>
-              <a:rPr lang="en-US" smtClean="0"/>
+              <a:rPr lang="en-US"/>
               <a:t>Click to edit Master text styles</a:t>
             </a:r>
           </a:p>
           <a:p>
             <a:pPr lvl="1"/>
             <a:r>
-              <a:rPr lang="en-US" smtClean="0"/>
+              <a:rPr lang="en-US"/>
               <a:t>Second level</a:t>
             </a:r>
           </a:p>
           <a:p>
             <a:pPr lvl="2"/>
             <a:r>
-              <a:rPr lang="en-US" smtClean="0"/>
+              <a:rPr lang="en-US"/>
               <a:t>Third level</a:t>
             </a:r>
           </a:p>
           <a:p>
             <a:pPr lvl="3"/>
             <a:r>
-              <a:rPr lang="en-US" smtClean="0"/>
+              <a:rPr lang="en-US"/>
               <a:t>Fourth level</a:t>
             </a:r>
           </a:p>
           <a:p>
             <a:pPr lvl="4"/>
             <a:r>
-              <a:rPr lang="en-US" smtClean="0"/>
+              <a:rPr lang="en-US"/>
               <a:t>Fifth level</a:t>
             </a:r>
-            <a:endParaRPr lang="en-US"/>
           </a:p>
         </p:txBody>
       </p:sp>
@@ -3921,7 +3694,7 @@
           <a:p>
             <a:fld id="{5BCAD085-E8A6-8845-BD4E-CB4CCA059FC4}" type="datetimeFigureOut">
               <a:rPr lang="en-US" smtClean="0"/>
-              <a:t>1/27/13</a:t>
+              <a:t>6/24/2026</a:t>
             </a:fld>
             <a:endParaRPr lang="en-US"/>
           </a:p>
@@ -4280,7 +4053,7 @@
 </file>
 
 <file path=ppt/slides/slide1.xml><?xml version="1.0" encoding="utf-8"?>
-<p:sld xmlns:a="http://schemas.openxmlformats.org/drawingml/2006/main" xmlns:p="http://schemas.openxmlformats.org/presentationml/2006/main" xmlns:r="http://schemas.openxmlformats.org/officeDocument/2006/relationships">
+<p:sld xmlns:a="http://schemas.openxmlformats.org/drawingml/2006/main" xmlns:r="http://schemas.openxmlformats.org/officeDocument/2006/relationships" xmlns:p="http://schemas.openxmlformats.org/presentationml/2006/main">
   <p:cSld>
     <p:bg>
       <p:bgPr>
@@ -4296,7 +4069,14 @@
         <p:cNvGrpSpPr/>
         <p:nvPr/>
       </p:nvGrpSpPr>
-      <p:grpSpPr/>
+      <p:grpSpPr>
+        <a:xfrm>
+          <a:off x="0" y="0"/>
+          <a:ext cx="0" cy="0"/>
+          <a:chOff x="0" y="0"/>
+          <a:chExt cx="0" cy="0"/>
+        </a:xfrm>
+      </p:grpSpPr>
       <p:sp>
         <p:nvSpPr>
           <p:cNvPr id="2" name="Rectangle 1"/>
@@ -4337,6 +4117,7 @@
           <a:lstStyle/>
           <a:p>
             <a:pPr algn="ctr"/>
+            <a:endParaRPr/>
           </a:p>
         </p:txBody>
       </p:sp>
@@ -4452,6 +4233,7 @@
           <a:lstStyle/>
           <a:p>
             <a:pPr algn="ctr"/>
+            <a:endParaRPr/>
           </a:p>
         </p:txBody>
       </p:sp>
@@ -4572,7 +4354,7 @@
           <p:nvPr/>
         </p:nvPicPr>
         <p:blipFill>
-          <a:blip r:embed="rId2"/>
+          <a:blip r:embed="rId3"/>
           <a:stretch>
             <a:fillRect/>
           </a:stretch>
@@ -4596,7 +4378,7 @@
 </file>
 
 <file path=ppt/slides/slide10.xml><?xml version="1.0" encoding="utf-8"?>
-<p:sld xmlns:a="http://schemas.openxmlformats.org/drawingml/2006/main" xmlns:p="http://schemas.openxmlformats.org/presentationml/2006/main" xmlns:r="http://schemas.openxmlformats.org/officeDocument/2006/relationships">
+<p:sld xmlns:a="http://schemas.openxmlformats.org/drawingml/2006/main" xmlns:r="http://schemas.openxmlformats.org/officeDocument/2006/relationships" xmlns:p="http://schemas.openxmlformats.org/presentationml/2006/main">
   <p:cSld>
     <p:bg>
       <p:bgPr>
@@ -4612,7 +4394,14 @@
         <p:cNvGrpSpPr/>
         <p:nvPr/>
       </p:nvGrpSpPr>
-      <p:grpSpPr/>
+      <p:grpSpPr>
+        <a:xfrm>
+          <a:off x="0" y="0"/>
+          <a:ext cx="0" cy="0"/>
+          <a:chOff x="0" y="0"/>
+          <a:chExt cx="0" cy="0"/>
+        </a:xfrm>
+      </p:grpSpPr>
       <p:sp>
         <p:nvSpPr>
           <p:cNvPr id="2" name="TextBox 1"/>
@@ -4689,6 +4478,7 @@
           <a:lstStyle/>
           <a:p>
             <a:pPr algn="ctr"/>
+            <a:endParaRPr/>
           </a:p>
         </p:txBody>
       </p:sp>
@@ -4732,6 +4522,7 @@
           <a:lstStyle/>
           <a:p>
             <a:pPr algn="ctr"/>
+            <a:endParaRPr/>
           </a:p>
         </p:txBody>
       </p:sp>
@@ -4847,6 +4638,7 @@
           <a:lstStyle/>
           <a:p>
             <a:pPr algn="ctr"/>
+            <a:endParaRPr/>
           </a:p>
         </p:txBody>
       </p:sp>
@@ -4962,6 +4754,7 @@
           <a:lstStyle/>
           <a:p>
             <a:pPr algn="ctr"/>
+            <a:endParaRPr/>
           </a:p>
         </p:txBody>
       </p:sp>
@@ -5077,6 +4870,7 @@
           <a:lstStyle/>
           <a:p>
             <a:pPr algn="ctr"/>
+            <a:endParaRPr/>
           </a:p>
         </p:txBody>
       </p:sp>
@@ -5192,6 +4986,7 @@
           <a:lstStyle/>
           <a:p>
             <a:pPr algn="ctr"/>
+            <a:endParaRPr/>
           </a:p>
         </p:txBody>
       </p:sp>
@@ -5307,6 +5102,7 @@
           <a:lstStyle/>
           <a:p>
             <a:pPr algn="ctr"/>
+            <a:endParaRPr/>
           </a:p>
         </p:txBody>
       </p:sp>
@@ -5391,7 +5187,7 @@
 </file>
 
 <file path=ppt/slides/slide11.xml><?xml version="1.0" encoding="utf-8"?>
-<p:sld xmlns:a="http://schemas.openxmlformats.org/drawingml/2006/main" xmlns:p="http://schemas.openxmlformats.org/presentationml/2006/main" xmlns:r="http://schemas.openxmlformats.org/officeDocument/2006/relationships">
+<p:sld xmlns:a="http://schemas.openxmlformats.org/drawingml/2006/main" xmlns:r="http://schemas.openxmlformats.org/officeDocument/2006/relationships" xmlns:p="http://schemas.openxmlformats.org/presentationml/2006/main">
   <p:cSld>
     <p:bg>
       <p:bgPr>
@@ -5407,7 +5203,14 @@
         <p:cNvGrpSpPr/>
         <p:nvPr/>
       </p:nvGrpSpPr>
-      <p:grpSpPr/>
+      <p:grpSpPr>
+        <a:xfrm>
+          <a:off x="0" y="0"/>
+          <a:ext cx="0" cy="0"/>
+          <a:chOff x="0" y="0"/>
+          <a:chExt cx="0" cy="0"/>
+        </a:xfrm>
+      </p:grpSpPr>
       <p:sp>
         <p:nvSpPr>
           <p:cNvPr id="2" name="TextBox 1"/>
@@ -5484,6 +5287,7 @@
           <a:lstStyle/>
           <a:p>
             <a:pPr algn="ctr"/>
+            <a:endParaRPr/>
           </a:p>
         </p:txBody>
       </p:sp>
@@ -5527,6 +5331,7 @@
           <a:lstStyle/>
           <a:p>
             <a:pPr algn="ctr"/>
+            <a:endParaRPr/>
           </a:p>
         </p:txBody>
       </p:sp>
@@ -5682,6 +5487,7 @@
           <a:lstStyle/>
           <a:p>
             <a:pPr algn="ctr"/>
+            <a:endParaRPr/>
           </a:p>
         </p:txBody>
       </p:sp>
@@ -5837,6 +5643,7 @@
           <a:lstStyle/>
           <a:p>
             <a:pPr algn="ctr"/>
+            <a:endParaRPr/>
           </a:p>
         </p:txBody>
       </p:sp>
@@ -6084,7 +5891,7 @@
 </file>
 
 <file path=ppt/slides/slide12.xml><?xml version="1.0" encoding="utf-8"?>
-<p:sld xmlns:a="http://schemas.openxmlformats.org/drawingml/2006/main" xmlns:p="http://schemas.openxmlformats.org/presentationml/2006/main" xmlns:r="http://schemas.openxmlformats.org/officeDocument/2006/relationships">
+<p:sld xmlns:a="http://schemas.openxmlformats.org/drawingml/2006/main" xmlns:r="http://schemas.openxmlformats.org/officeDocument/2006/relationships" xmlns:p="http://schemas.openxmlformats.org/presentationml/2006/main">
   <p:cSld>
     <p:bg>
       <p:bgPr>
@@ -6100,7 +5907,14 @@
         <p:cNvGrpSpPr/>
         <p:nvPr/>
       </p:nvGrpSpPr>
-      <p:grpSpPr/>
+      <p:grpSpPr>
+        <a:xfrm>
+          <a:off x="0" y="0"/>
+          <a:ext cx="0" cy="0"/>
+          <a:chOff x="0" y="0"/>
+          <a:chExt cx="0" cy="0"/>
+        </a:xfrm>
+      </p:grpSpPr>
       <p:sp>
         <p:nvSpPr>
           <p:cNvPr id="2" name="Rectangle 1"/>
@@ -6141,6 +5955,7 @@
           <a:lstStyle/>
           <a:p>
             <a:pPr algn="ctr"/>
+            <a:endParaRPr/>
           </a:p>
         </p:txBody>
       </p:sp>
@@ -6220,6 +6035,7 @@
           <a:lstStyle/>
           <a:p>
             <a:pPr algn="ctr"/>
+            <a:endParaRPr/>
           </a:p>
         </p:txBody>
       </p:sp>
@@ -6391,7 +6207,7 @@
 </file>
 
 <file path=ppt/slides/slide2.xml><?xml version="1.0" encoding="utf-8"?>
-<p:sld xmlns:a="http://schemas.openxmlformats.org/drawingml/2006/main" xmlns:p="http://schemas.openxmlformats.org/presentationml/2006/main" xmlns:r="http://schemas.openxmlformats.org/officeDocument/2006/relationships">
+<p:sld xmlns:a="http://schemas.openxmlformats.org/drawingml/2006/main" xmlns:r="http://schemas.openxmlformats.org/officeDocument/2006/relationships" xmlns:p="http://schemas.openxmlformats.org/presentationml/2006/main">
   <p:cSld>
     <p:bg>
       <p:bgPr>
@@ -6407,7 +6223,14 @@
         <p:cNvGrpSpPr/>
         <p:nvPr/>
       </p:nvGrpSpPr>
-      <p:grpSpPr/>
+      <p:grpSpPr>
+        <a:xfrm>
+          <a:off x="0" y="0"/>
+          <a:ext cx="0" cy="0"/>
+          <a:chOff x="0" y="0"/>
+          <a:chExt cx="0" cy="0"/>
+        </a:xfrm>
+      </p:grpSpPr>
       <p:sp>
         <p:nvSpPr>
           <p:cNvPr id="2" name="TextBox 1"/>
@@ -6484,6 +6307,7 @@
           <a:lstStyle/>
           <a:p>
             <a:pPr algn="ctr"/>
+            <a:endParaRPr/>
           </a:p>
         </p:txBody>
       </p:sp>
@@ -6563,6 +6387,7 @@
           <a:lstStyle/>
           <a:p>
             <a:pPr algn="ctr"/>
+            <a:endParaRPr/>
           </a:p>
         </p:txBody>
       </p:sp>
@@ -6714,6 +6539,7 @@
           <a:lstStyle/>
           <a:p>
             <a:pPr algn="ctr"/>
+            <a:endParaRPr/>
           </a:p>
         </p:txBody>
       </p:sp>
@@ -6865,6 +6691,7 @@
           <a:lstStyle/>
           <a:p>
             <a:pPr algn="ctr"/>
+            <a:endParaRPr/>
           </a:p>
         </p:txBody>
       </p:sp>
@@ -7016,6 +6843,7 @@
           <a:lstStyle/>
           <a:p>
             <a:pPr algn="ctr"/>
+            <a:endParaRPr/>
           </a:p>
         </p:txBody>
       </p:sp>
@@ -7172,7 +7000,7 @@
 </file>
 
 <file path=ppt/slides/slide3.xml><?xml version="1.0" encoding="utf-8"?>
-<p:sld xmlns:a="http://schemas.openxmlformats.org/drawingml/2006/main" xmlns:p="http://schemas.openxmlformats.org/presentationml/2006/main" xmlns:r="http://schemas.openxmlformats.org/officeDocument/2006/relationships">
+<p:sld xmlns:a="http://schemas.openxmlformats.org/drawingml/2006/main" xmlns:r="http://schemas.openxmlformats.org/officeDocument/2006/relationships" xmlns:p="http://schemas.openxmlformats.org/presentationml/2006/main">
   <p:cSld>
     <p:bg>
       <p:bgPr>
@@ -7188,7 +7016,14 @@
         <p:cNvGrpSpPr/>
         <p:nvPr/>
       </p:nvGrpSpPr>
-      <p:grpSpPr/>
+      <p:grpSpPr>
+        <a:xfrm>
+          <a:off x="0" y="0"/>
+          <a:ext cx="0" cy="0"/>
+          <a:chOff x="0" y="0"/>
+          <a:chExt cx="0" cy="0"/>
+        </a:xfrm>
+      </p:grpSpPr>
       <p:sp>
         <p:nvSpPr>
           <p:cNvPr id="2" name="TextBox 1"/>
@@ -7265,6 +7100,7 @@
           <a:lstStyle/>
           <a:p>
             <a:pPr algn="ctr"/>
+            <a:endParaRPr/>
           </a:p>
         </p:txBody>
       </p:sp>
@@ -7308,6 +7144,7 @@
           <a:lstStyle/>
           <a:p>
             <a:pPr algn="ctr"/>
+            <a:endParaRPr/>
           </a:p>
         </p:txBody>
       </p:sp>
@@ -7467,6 +7304,7 @@
           <a:lstStyle/>
           <a:p>
             <a:pPr algn="ctr"/>
+            <a:endParaRPr/>
           </a:p>
         </p:txBody>
       </p:sp>
@@ -7626,6 +7464,7 @@
           <a:lstStyle/>
           <a:p>
             <a:pPr algn="ctr"/>
+            <a:endParaRPr/>
           </a:p>
         </p:txBody>
       </p:sp>
@@ -7785,6 +7624,7 @@
           <a:lstStyle/>
           <a:p>
             <a:pPr algn="ctr"/>
+            <a:endParaRPr/>
           </a:p>
         </p:txBody>
       </p:sp>
@@ -7944,6 +7784,7 @@
           <a:lstStyle/>
           <a:p>
             <a:pPr algn="ctr"/>
+            <a:endParaRPr/>
           </a:p>
         </p:txBody>
       </p:sp>
@@ -8072,7 +7913,7 @@
 </file>
 
 <file path=ppt/slides/slide4.xml><?xml version="1.0" encoding="utf-8"?>
-<p:sld xmlns:a="http://schemas.openxmlformats.org/drawingml/2006/main" xmlns:p="http://schemas.openxmlformats.org/presentationml/2006/main" xmlns:r="http://schemas.openxmlformats.org/officeDocument/2006/relationships">
+<p:sld xmlns:a="http://schemas.openxmlformats.org/drawingml/2006/main" xmlns:r="http://schemas.openxmlformats.org/officeDocument/2006/relationships" xmlns:p="http://schemas.openxmlformats.org/presentationml/2006/main">
   <p:cSld>
     <p:bg>
       <p:bgPr>
@@ -8088,7 +7929,14 @@
         <p:cNvGrpSpPr/>
         <p:nvPr/>
       </p:nvGrpSpPr>
-      <p:grpSpPr/>
+      <p:grpSpPr>
+        <a:xfrm>
+          <a:off x="0" y="0"/>
+          <a:ext cx="0" cy="0"/>
+          <a:chOff x="0" y="0"/>
+          <a:chExt cx="0" cy="0"/>
+        </a:xfrm>
+      </p:grpSpPr>
       <p:sp>
         <p:nvSpPr>
           <p:cNvPr id="2" name="TextBox 1"/>
@@ -8165,6 +8013,7 @@
           <a:lstStyle/>
           <a:p>
             <a:pPr algn="ctr"/>
+            <a:endParaRPr/>
           </a:p>
         </p:txBody>
       </p:sp>
@@ -8213,15 +8062,15 @@
           <p:nvPr/>
         </p:nvPicPr>
         <p:blipFill>
-          <a:blip r:embed="rId2"/>
+          <a:blip r:embed="rId3"/>
           <a:stretch>
             <a:fillRect/>
           </a:stretch>
         </p:blipFill>
         <p:spPr>
           <a:xfrm>
-            <a:off x="1371600" y="1645920"/>
-            <a:ext cx="9418320" cy="9796870"/>
+            <a:off x="1282127" y="1554480"/>
+            <a:ext cx="8329656" cy="5092126"/>
           </a:xfrm>
           <a:prstGeom prst="rect">
             <a:avLst/>
@@ -8237,7 +8086,7 @@
 </file>
 
 <file path=ppt/slides/slide5.xml><?xml version="1.0" encoding="utf-8"?>
-<p:sld xmlns:a="http://schemas.openxmlformats.org/drawingml/2006/main" xmlns:p="http://schemas.openxmlformats.org/presentationml/2006/main" xmlns:r="http://schemas.openxmlformats.org/officeDocument/2006/relationships">
+<p:sld xmlns:a="http://schemas.openxmlformats.org/drawingml/2006/main" xmlns:r="http://schemas.openxmlformats.org/officeDocument/2006/relationships" xmlns:p="http://schemas.openxmlformats.org/presentationml/2006/main">
   <p:cSld>
     <p:bg>
       <p:bgPr>
@@ -8253,7 +8102,14 @@
         <p:cNvGrpSpPr/>
         <p:nvPr/>
       </p:nvGrpSpPr>
-      <p:grpSpPr/>
+      <p:grpSpPr>
+        <a:xfrm>
+          <a:off x="0" y="0"/>
+          <a:ext cx="0" cy="0"/>
+          <a:chOff x="0" y="0"/>
+          <a:chExt cx="0" cy="0"/>
+        </a:xfrm>
+      </p:grpSpPr>
       <p:sp>
         <p:nvSpPr>
           <p:cNvPr id="2" name="TextBox 1"/>
@@ -8330,6 +8186,7 @@
           <a:lstStyle/>
           <a:p>
             <a:pPr algn="ctr"/>
+            <a:endParaRPr/>
           </a:p>
         </p:txBody>
       </p:sp>
@@ -8373,6 +8230,7 @@
           <a:lstStyle/>
           <a:p>
             <a:pPr algn="ctr"/>
+            <a:endParaRPr/>
           </a:p>
         </p:txBody>
       </p:sp>
@@ -8528,6 +8386,7 @@
           <a:lstStyle/>
           <a:p>
             <a:pPr algn="ctr"/>
+            <a:endParaRPr/>
           </a:p>
         </p:txBody>
       </p:sp>
@@ -8683,6 +8542,7 @@
           <a:lstStyle/>
           <a:p>
             <a:pPr algn="ctr"/>
+            <a:endParaRPr/>
           </a:p>
         </p:txBody>
       </p:sp>
@@ -8838,6 +8698,7 @@
           <a:lstStyle/>
           <a:p>
             <a:pPr algn="ctr"/>
+            <a:endParaRPr/>
           </a:p>
         </p:txBody>
       </p:sp>
@@ -8993,6 +8854,7 @@
           <a:lstStyle/>
           <a:p>
             <a:pPr algn="ctr"/>
+            <a:endParaRPr/>
           </a:p>
         </p:txBody>
       </p:sp>
@@ -9148,6 +9010,7 @@
           <a:lstStyle/>
           <a:p>
             <a:pPr algn="ctr"/>
+            <a:endParaRPr/>
           </a:p>
         </p:txBody>
       </p:sp>
@@ -9303,6 +9166,7 @@
           <a:lstStyle/>
           <a:p>
             <a:pPr algn="ctr"/>
+            <a:endParaRPr/>
           </a:p>
         </p:txBody>
       </p:sp>
@@ -9427,7 +9291,7 @@
 </file>
 
 <file path=ppt/slides/slide6.xml><?xml version="1.0" encoding="utf-8"?>
-<p:sld xmlns:a="http://schemas.openxmlformats.org/drawingml/2006/main" xmlns:p="http://schemas.openxmlformats.org/presentationml/2006/main" xmlns:r="http://schemas.openxmlformats.org/officeDocument/2006/relationships">
+<p:sld xmlns:a="http://schemas.openxmlformats.org/drawingml/2006/main" xmlns:r="http://schemas.openxmlformats.org/officeDocument/2006/relationships" xmlns:p="http://schemas.openxmlformats.org/presentationml/2006/main">
   <p:cSld>
     <p:bg>
       <p:bgPr>
@@ -9443,7 +9307,14 @@
         <p:cNvGrpSpPr/>
         <p:nvPr/>
       </p:nvGrpSpPr>
-      <p:grpSpPr/>
+      <p:grpSpPr>
+        <a:xfrm>
+          <a:off x="0" y="0"/>
+          <a:ext cx="0" cy="0"/>
+          <a:chOff x="0" y="0"/>
+          <a:chExt cx="0" cy="0"/>
+        </a:xfrm>
+      </p:grpSpPr>
       <p:sp>
         <p:nvSpPr>
           <p:cNvPr id="2" name="TextBox 1"/>
@@ -9520,6 +9391,7 @@
           <a:lstStyle/>
           <a:p>
             <a:pPr algn="ctr"/>
+            <a:endParaRPr/>
           </a:p>
         </p:txBody>
       </p:sp>
@@ -9599,6 +9471,7 @@
           <a:lstStyle/>
           <a:p>
             <a:pPr algn="ctr"/>
+            <a:endParaRPr/>
           </a:p>
         </p:txBody>
       </p:sp>
@@ -9682,6 +9555,7 @@
           <a:lstStyle/>
           <a:p>
             <a:pPr algn="ctr"/>
+            <a:endParaRPr/>
           </a:p>
         </p:txBody>
       </p:sp>
@@ -9725,6 +9599,7 @@
           <a:lstStyle/>
           <a:p>
             <a:pPr algn="ctr"/>
+            <a:endParaRPr/>
           </a:p>
         </p:txBody>
       </p:sp>
@@ -9808,6 +9683,7 @@
           <a:lstStyle/>
           <a:p>
             <a:pPr algn="ctr"/>
+            <a:endParaRPr/>
           </a:p>
         </p:txBody>
       </p:sp>
@@ -9851,6 +9727,7 @@
           <a:lstStyle/>
           <a:p>
             <a:pPr algn="ctr"/>
+            <a:endParaRPr/>
           </a:p>
         </p:txBody>
       </p:sp>
@@ -9934,6 +9811,7 @@
           <a:lstStyle/>
           <a:p>
             <a:pPr algn="ctr"/>
+            <a:endParaRPr/>
           </a:p>
         </p:txBody>
       </p:sp>
@@ -9977,6 +9855,7 @@
           <a:lstStyle/>
           <a:p>
             <a:pPr algn="ctr"/>
+            <a:endParaRPr/>
           </a:p>
         </p:txBody>
       </p:sp>
@@ -10060,6 +9939,7 @@
           <a:lstStyle/>
           <a:p>
             <a:pPr algn="ctr"/>
+            <a:endParaRPr/>
           </a:p>
         </p:txBody>
       </p:sp>
@@ -10103,6 +9983,7 @@
           <a:lstStyle/>
           <a:p>
             <a:pPr algn="ctr"/>
+            <a:endParaRPr/>
           </a:p>
         </p:txBody>
       </p:sp>
@@ -10186,6 +10067,7 @@
           <a:lstStyle/>
           <a:p>
             <a:pPr algn="ctr"/>
+            <a:endParaRPr/>
           </a:p>
         </p:txBody>
       </p:sp>
@@ -10229,6 +10111,7 @@
           <a:lstStyle/>
           <a:p>
             <a:pPr algn="ctr"/>
+            <a:endParaRPr/>
           </a:p>
         </p:txBody>
       </p:sp>
@@ -10317,7 +10200,7 @@
 </file>
 
 <file path=ppt/slides/slide7.xml><?xml version="1.0" encoding="utf-8"?>
-<p:sld xmlns:a="http://schemas.openxmlformats.org/drawingml/2006/main" xmlns:p="http://schemas.openxmlformats.org/presentationml/2006/main" xmlns:r="http://schemas.openxmlformats.org/officeDocument/2006/relationships">
+<p:sld xmlns:a="http://schemas.openxmlformats.org/drawingml/2006/main" xmlns:r="http://schemas.openxmlformats.org/officeDocument/2006/relationships" xmlns:p="http://schemas.openxmlformats.org/presentationml/2006/main">
   <p:cSld>
     <p:bg>
       <p:bgPr>
@@ -10333,7 +10216,14 @@
         <p:cNvGrpSpPr/>
         <p:nvPr/>
       </p:nvGrpSpPr>
-      <p:grpSpPr/>
+      <p:grpSpPr>
+        <a:xfrm>
+          <a:off x="0" y="0"/>
+          <a:ext cx="0" cy="0"/>
+          <a:chOff x="0" y="0"/>
+          <a:chExt cx="0" cy="0"/>
+        </a:xfrm>
+      </p:grpSpPr>
       <p:sp>
         <p:nvSpPr>
           <p:cNvPr id="2" name="TextBox 1"/>
@@ -10410,6 +10300,7 @@
           <a:lstStyle/>
           <a:p>
             <a:pPr algn="ctr"/>
+            <a:endParaRPr/>
           </a:p>
         </p:txBody>
       </p:sp>
@@ -10489,79 +10380,13 @@
           <a:lstStyle/>
           <a:p>
             <a:pPr algn="ctr"/>
+            <a:endParaRPr/>
           </a:p>
         </p:txBody>
       </p:sp>
       <p:pic>
         <p:nvPicPr>
           <p:cNvPr id="6" name="Picture 5" descr="aws_lambda_functions.png"/>
-          <p:cNvPicPr>
-            <a:picLocks noChangeAspect="1"/>
-          </p:cNvPicPr>
-          <p:nvPr/>
-        </p:nvPicPr>
-        <p:blipFill>
-          <a:blip r:embed="rId2"/>
-          <a:stretch>
-            <a:fillRect/>
-          </a:stretch>
-        </p:blipFill>
-        <p:spPr>
-          <a:xfrm>
-            <a:off x="640080" y="1783080"/>
-            <a:ext cx="4937760" cy="2229458"/>
-          </a:xfrm>
-          <a:prstGeom prst="rect">
-            <a:avLst/>
-          </a:prstGeom>
-        </p:spPr>
-      </p:pic>
-      <p:sp>
-        <p:nvSpPr>
-          <p:cNvPr id="7" name="Rounded Rectangle 6"/>
-          <p:cNvSpPr/>
-          <p:nvPr/>
-        </p:nvSpPr>
-        <p:spPr>
-          <a:xfrm>
-            <a:off x="6217920" y="1645920"/>
-            <a:ext cx="5303520" cy="2194560"/>
-          </a:xfrm>
-          <a:prstGeom prst="roundRect">
-            <a:avLst/>
-          </a:prstGeom>
-          <a:solidFill>
-            <a:srgbClr val="1E293B"/>
-          </a:solidFill>
-          <a:ln>
-            <a:noFill/>
-          </a:ln>
-        </p:spPr>
-        <p:style>
-          <a:lnRef idx="1">
-            <a:schemeClr val="accent1"/>
-          </a:lnRef>
-          <a:fillRef idx="3">
-            <a:schemeClr val="accent1"/>
-          </a:fillRef>
-          <a:effectRef idx="2">
-            <a:schemeClr val="accent1"/>
-          </a:effectRef>
-          <a:fontRef idx="minor">
-            <a:schemeClr val="lt1"/>
-          </a:fontRef>
-        </p:style>
-        <p:txBody>
-          <a:bodyPr rtlCol="0" anchor="ctr"/>
-          <a:lstStyle/>
-          <a:p>
-            <a:pPr algn="ctr"/>
-          </a:p>
-        </p:txBody>
-      </p:sp>
-      <p:pic>
-        <p:nvPicPr>
-          <p:cNvPr id="8" name="Picture 7" descr="aws_api_gateway_resources.png"/>
           <p:cNvPicPr>
             <a:picLocks noChangeAspect="1"/>
           </p:cNvPicPr>
@@ -10575,8 +10400,8 @@
         </p:blipFill>
         <p:spPr>
           <a:xfrm>
-            <a:off x="6400800" y="1783080"/>
-            <a:ext cx="4937760" cy="2253803"/>
+            <a:off x="649912" y="1792912"/>
+            <a:ext cx="4937760" cy="2229458"/>
           </a:xfrm>
           <a:prstGeom prst="rect">
             <a:avLst/>
@@ -10585,14 +10410,14 @@
       </p:pic>
       <p:sp>
         <p:nvSpPr>
-          <p:cNvPr id="9" name="Rounded Rectangle 8"/>
+          <p:cNvPr id="7" name="Rounded Rectangle 6"/>
           <p:cNvSpPr/>
           <p:nvPr/>
         </p:nvSpPr>
         <p:spPr>
           <a:xfrm>
-            <a:off x="6217920" y="4114800"/>
-            <a:ext cx="5303520" cy="2286000"/>
+            <a:off x="6217920" y="1645920"/>
+            <a:ext cx="5303520" cy="2194560"/>
           </a:xfrm>
           <a:prstGeom prst="roundRect">
             <a:avLst/>
@@ -10623,12 +10448,13 @@
           <a:lstStyle/>
           <a:p>
             <a:pPr algn="ctr"/>
+            <a:endParaRPr/>
           </a:p>
         </p:txBody>
       </p:sp>
       <p:pic>
         <p:nvPicPr>
-          <p:cNvPr id="10" name="Picture 9" descr="aws_cloudwatch_logs.png"/>
+          <p:cNvPr id="8" name="Picture 7" descr="aws_api_gateway_resources.png"/>
           <p:cNvPicPr>
             <a:picLocks noChangeAspect="1"/>
           </p:cNvPicPr>
@@ -10642,8 +10468,76 @@
         </p:blipFill>
         <p:spPr>
           <a:xfrm>
-            <a:off x="6400800" y="4251960"/>
-            <a:ext cx="4937760" cy="2244904"/>
+            <a:off x="6400800" y="1783080"/>
+            <a:ext cx="4937760" cy="2253803"/>
+          </a:xfrm>
+          <a:prstGeom prst="rect">
+            <a:avLst/>
+          </a:prstGeom>
+        </p:spPr>
+      </p:pic>
+      <p:sp>
+        <p:nvSpPr>
+          <p:cNvPr id="9" name="Rounded Rectangle 8"/>
+          <p:cNvSpPr/>
+          <p:nvPr/>
+        </p:nvSpPr>
+        <p:spPr>
+          <a:xfrm>
+            <a:off x="6217920" y="4114800"/>
+            <a:ext cx="5303520" cy="2286000"/>
+          </a:xfrm>
+          <a:prstGeom prst="roundRect">
+            <a:avLst/>
+          </a:prstGeom>
+          <a:solidFill>
+            <a:srgbClr val="1E293B"/>
+          </a:solidFill>
+          <a:ln>
+            <a:noFill/>
+          </a:ln>
+        </p:spPr>
+        <p:style>
+          <a:lnRef idx="1">
+            <a:schemeClr val="accent1"/>
+          </a:lnRef>
+          <a:fillRef idx="3">
+            <a:schemeClr val="accent1"/>
+          </a:fillRef>
+          <a:effectRef idx="2">
+            <a:schemeClr val="accent1"/>
+          </a:effectRef>
+          <a:fontRef idx="minor">
+            <a:schemeClr val="lt1"/>
+          </a:fontRef>
+        </p:style>
+        <p:txBody>
+          <a:bodyPr rtlCol="0" anchor="ctr"/>
+          <a:lstStyle/>
+          <a:p>
+            <a:pPr algn="ctr"/>
+            <a:endParaRPr/>
+          </a:p>
+        </p:txBody>
+      </p:sp>
+      <p:pic>
+        <p:nvPicPr>
+          <p:cNvPr id="10" name="Picture 9" descr="aws_cloudwatch_logs.png"/>
+          <p:cNvPicPr>
+            <a:picLocks noChangeAspect="1"/>
+          </p:cNvPicPr>
+          <p:nvPr/>
+        </p:nvPicPr>
+        <p:blipFill>
+          <a:blip r:embed="rId5"/>
+          <a:stretch>
+            <a:fillRect/>
+          </a:stretch>
+        </p:blipFill>
+        <p:spPr>
+          <a:xfrm>
+            <a:off x="6400800" y="4036883"/>
+            <a:ext cx="4937760" cy="2459981"/>
           </a:xfrm>
           <a:prstGeom prst="rect">
             <a:avLst/>
@@ -10659,7 +10553,7 @@
 </file>
 
 <file path=ppt/slides/slide8.xml><?xml version="1.0" encoding="utf-8"?>
-<p:sld xmlns:a="http://schemas.openxmlformats.org/drawingml/2006/main" xmlns:p="http://schemas.openxmlformats.org/presentationml/2006/main" xmlns:r="http://schemas.openxmlformats.org/officeDocument/2006/relationships">
+<p:sld xmlns:a="http://schemas.openxmlformats.org/drawingml/2006/main" xmlns:r="http://schemas.openxmlformats.org/officeDocument/2006/relationships" xmlns:p="http://schemas.openxmlformats.org/presentationml/2006/main">
   <p:cSld>
     <p:bg>
       <p:bgPr>
@@ -10675,7 +10569,14 @@
         <p:cNvGrpSpPr/>
         <p:nvPr/>
       </p:nvGrpSpPr>
-      <p:grpSpPr/>
+      <p:grpSpPr>
+        <a:xfrm>
+          <a:off x="0" y="0"/>
+          <a:ext cx="0" cy="0"/>
+          <a:chOff x="0" y="0"/>
+          <a:chExt cx="0" cy="0"/>
+        </a:xfrm>
+      </p:grpSpPr>
       <p:sp>
         <p:nvSpPr>
           <p:cNvPr id="2" name="TextBox 1"/>
@@ -10752,6 +10653,7 @@
           <a:lstStyle/>
           <a:p>
             <a:pPr algn="ctr"/>
+            <a:endParaRPr/>
           </a:p>
         </p:txBody>
       </p:sp>
@@ -10831,6 +10733,7 @@
           <a:lstStyle/>
           <a:p>
             <a:pPr algn="ctr"/>
+            <a:endParaRPr/>
           </a:p>
         </p:txBody>
       </p:sp>
@@ -10879,7 +10782,7 @@
           <p:nvPr/>
         </p:nvPicPr>
         <p:blipFill>
-          <a:blip r:embed="rId2"/>
+          <a:blip r:embed="rId3"/>
           <a:stretch>
             <a:fillRect/>
           </a:stretch>
@@ -10934,6 +10837,7 @@
           <a:lstStyle/>
           <a:p>
             <a:pPr algn="ctr"/>
+            <a:endParaRPr/>
           </a:p>
         </p:txBody>
       </p:sp>
@@ -10982,7 +10886,7 @@
           <p:nvPr/>
         </p:nvPicPr>
         <p:blipFill>
-          <a:blip r:embed="rId3"/>
+          <a:blip r:embed="rId4"/>
           <a:stretch>
             <a:fillRect/>
           </a:stretch>
@@ -11006,7 +10910,7 @@
 </file>
 
 <file path=ppt/slides/slide9.xml><?xml version="1.0" encoding="utf-8"?>
-<p:sld xmlns:a="http://schemas.openxmlformats.org/drawingml/2006/main" xmlns:p="http://schemas.openxmlformats.org/presentationml/2006/main" xmlns:r="http://schemas.openxmlformats.org/officeDocument/2006/relationships">
+<p:sld xmlns:a="http://schemas.openxmlformats.org/drawingml/2006/main" xmlns:r="http://schemas.openxmlformats.org/officeDocument/2006/relationships" xmlns:p="http://schemas.openxmlformats.org/presentationml/2006/main">
   <p:cSld>
     <p:bg>
       <p:bgPr>
@@ -11022,7 +10926,14 @@
         <p:cNvGrpSpPr/>
         <p:nvPr/>
       </p:nvGrpSpPr>
-      <p:grpSpPr/>
+      <p:grpSpPr>
+        <a:xfrm>
+          <a:off x="0" y="0"/>
+          <a:ext cx="0" cy="0"/>
+          <a:chOff x="0" y="0"/>
+          <a:chExt cx="0" cy="0"/>
+        </a:xfrm>
+      </p:grpSpPr>
       <p:sp>
         <p:nvSpPr>
           <p:cNvPr id="2" name="TextBox 1"/>
@@ -11099,6 +11010,7 @@
           <a:lstStyle/>
           <a:p>
             <a:pPr algn="ctr"/>
+            <a:endParaRPr/>
           </a:p>
         </p:txBody>
       </p:sp>
@@ -11178,79 +11090,13 @@
           <a:lstStyle/>
           <a:p>
             <a:pPr algn="ctr"/>
+            <a:endParaRPr/>
           </a:p>
         </p:txBody>
       </p:sp>
       <p:pic>
         <p:nvPicPr>
           <p:cNvPr id="6" name="Picture 5" descr="dashboard.png"/>
-          <p:cNvPicPr>
-            <a:picLocks noChangeAspect="1"/>
-          </p:cNvPicPr>
-          <p:nvPr/>
-        </p:nvPicPr>
-        <p:blipFill>
-          <a:blip r:embed="rId2"/>
-          <a:stretch>
-            <a:fillRect/>
-          </a:stretch>
-        </p:blipFill>
-        <p:spPr>
-          <a:xfrm>
-            <a:off x="640080" y="1691640"/>
-            <a:ext cx="5120640" cy="2316097"/>
-          </a:xfrm>
-          <a:prstGeom prst="rect">
-            <a:avLst/>
-          </a:prstGeom>
-        </p:spPr>
-      </p:pic>
-      <p:sp>
-        <p:nvSpPr>
-          <p:cNvPr id="7" name="Rounded Rectangle 6"/>
-          <p:cNvSpPr/>
-          <p:nvPr/>
-        </p:nvSpPr>
-        <p:spPr>
-          <a:xfrm>
-            <a:off x="6217920" y="1554480"/>
-            <a:ext cx="5303520" cy="2286000"/>
-          </a:xfrm>
-          <a:prstGeom prst="roundRect">
-            <a:avLst/>
-          </a:prstGeom>
-          <a:solidFill>
-            <a:srgbClr val="1E293B"/>
-          </a:solidFill>
-          <a:ln>
-            <a:noFill/>
-          </a:ln>
-        </p:spPr>
-        <p:style>
-          <a:lnRef idx="1">
-            <a:schemeClr val="accent1"/>
-          </a:lnRef>
-          <a:fillRef idx="3">
-            <a:schemeClr val="accent1"/>
-          </a:fillRef>
-          <a:effectRef idx="2">
-            <a:schemeClr val="accent1"/>
-          </a:effectRef>
-          <a:fontRef idx="minor">
-            <a:schemeClr val="lt1"/>
-          </a:fontRef>
-        </p:style>
-        <p:txBody>
-          <a:bodyPr rtlCol="0" anchor="ctr"/>
-          <a:lstStyle/>
-          <a:p>
-            <a:pPr algn="ctr"/>
-          </a:p>
-        </p:txBody>
-      </p:sp>
-      <p:pic>
-        <p:nvPicPr>
-          <p:cNvPr id="8" name="Picture 7" descr="live_prediction.png"/>
           <p:cNvPicPr>
             <a:picLocks noChangeAspect="1"/>
           </p:cNvPicPr>
@@ -11264,8 +11110,8 @@
         </p:blipFill>
         <p:spPr>
           <a:xfrm>
-            <a:off x="6400800" y="1691640"/>
-            <a:ext cx="4937760" cy="2584304"/>
+            <a:off x="640080" y="2519516"/>
+            <a:ext cx="5120640" cy="3611880"/>
           </a:xfrm>
           <a:prstGeom prst="rect">
             <a:avLst/>
@@ -11274,14 +11120,14 @@
       </p:pic>
       <p:sp>
         <p:nvSpPr>
-          <p:cNvPr id="9" name="Rounded Rectangle 8"/>
+          <p:cNvPr id="7" name="Rounded Rectangle 6"/>
           <p:cNvSpPr/>
           <p:nvPr/>
         </p:nvSpPr>
         <p:spPr>
           <a:xfrm>
-            <a:off x="6217920" y="4023360"/>
-            <a:ext cx="5303520" cy="2377440"/>
+            <a:off x="6217920" y="1554480"/>
+            <a:ext cx="5303520" cy="2286000"/>
           </a:xfrm>
           <a:prstGeom prst="roundRect">
             <a:avLst/>
@@ -11312,12 +11158,13 @@
           <a:lstStyle/>
           <a:p>
             <a:pPr algn="ctr"/>
+            <a:endParaRPr/>
           </a:p>
         </p:txBody>
       </p:sp>
       <p:pic>
         <p:nvPicPr>
-          <p:cNvPr id="10" name="Picture 9" descr="sentiment_analysis.png"/>
+          <p:cNvPr id="8" name="Picture 7" descr="live_prediction.png"/>
           <p:cNvPicPr>
             <a:picLocks noChangeAspect="1"/>
           </p:cNvPicPr>
@@ -11331,7 +11178,75 @@
         </p:blipFill>
         <p:spPr>
           <a:xfrm>
-            <a:off x="6400800" y="4160520"/>
+            <a:off x="6400800" y="1484776"/>
+            <a:ext cx="4937760" cy="2584304"/>
+          </a:xfrm>
+          <a:prstGeom prst="rect">
+            <a:avLst/>
+          </a:prstGeom>
+        </p:spPr>
+      </p:pic>
+      <p:sp>
+        <p:nvSpPr>
+          <p:cNvPr id="9" name="Rounded Rectangle 8"/>
+          <p:cNvSpPr/>
+          <p:nvPr/>
+        </p:nvSpPr>
+        <p:spPr>
+          <a:xfrm>
+            <a:off x="6217920" y="4023360"/>
+            <a:ext cx="5303520" cy="2377440"/>
+          </a:xfrm>
+          <a:prstGeom prst="roundRect">
+            <a:avLst/>
+          </a:prstGeom>
+          <a:solidFill>
+            <a:srgbClr val="1E293B"/>
+          </a:solidFill>
+          <a:ln>
+            <a:noFill/>
+          </a:ln>
+        </p:spPr>
+        <p:style>
+          <a:lnRef idx="1">
+            <a:schemeClr val="accent1"/>
+          </a:lnRef>
+          <a:fillRef idx="3">
+            <a:schemeClr val="accent1"/>
+          </a:fillRef>
+          <a:effectRef idx="2">
+            <a:schemeClr val="accent1"/>
+          </a:effectRef>
+          <a:fontRef idx="minor">
+            <a:schemeClr val="lt1"/>
+          </a:fontRef>
+        </p:style>
+        <p:txBody>
+          <a:bodyPr rtlCol="0" anchor="ctr"/>
+          <a:lstStyle/>
+          <a:p>
+            <a:pPr algn="ctr"/>
+            <a:endParaRPr/>
+          </a:p>
+        </p:txBody>
+      </p:sp>
+      <p:pic>
+        <p:nvPicPr>
+          <p:cNvPr id="10" name="Picture 9" descr="sentiment_analysis.png"/>
+          <p:cNvPicPr>
+            <a:picLocks noChangeAspect="1"/>
+          </p:cNvPicPr>
+          <p:nvPr/>
+        </p:nvPicPr>
+        <p:blipFill>
+          <a:blip r:embed="rId5"/>
+          <a:stretch>
+            <a:fillRect/>
+          </a:stretch>
+        </p:blipFill>
+        <p:spPr>
+          <a:xfrm>
+            <a:off x="6400800" y="3977640"/>
             <a:ext cx="4937760" cy="2636262"/>
           </a:xfrm>
           <a:prstGeom prst="rect">
@@ -11678,44 +11593,44 @@
         <a:sysClr val="window" lastClr="FFFFFF"/>
       </a:lt1>
       <a:dk2>
-        <a:srgbClr val="1F497D"/>
+        <a:srgbClr val="44546A"/>
       </a:dk2>
       <a:lt2>
-        <a:srgbClr val="EEECE1"/>
+        <a:srgbClr val="E7E6E6"/>
       </a:lt2>
       <a:accent1>
-        <a:srgbClr val="4F81BD"/>
+        <a:srgbClr val="4472C4"/>
       </a:accent1>
       <a:accent2>
-        <a:srgbClr val="C0504D"/>
+        <a:srgbClr val="ED7D31"/>
       </a:accent2>
       <a:accent3>
-        <a:srgbClr val="9BBB59"/>
+        <a:srgbClr val="A5A5A5"/>
       </a:accent3>
       <a:accent4>
-        <a:srgbClr val="8064A2"/>
+        <a:srgbClr val="FFC000"/>
       </a:accent4>
       <a:accent5>
-        <a:srgbClr val="4BACC6"/>
+        <a:srgbClr val="5B9BD5"/>
       </a:accent5>
       <a:accent6>
-        <a:srgbClr val="F79646"/>
+        <a:srgbClr val="70AD47"/>
       </a:accent6>
       <a:hlink>
-        <a:srgbClr val="0000FF"/>
+        <a:srgbClr val="0563C1"/>
       </a:hlink>
       <a:folHlink>
-        <a:srgbClr val="800080"/>
+        <a:srgbClr val="954F72"/>
       </a:folHlink>
     </a:clrScheme>
     <a:fontScheme name="Office">
       <a:majorFont>
-        <a:latin typeface="Calibri"/>
+        <a:latin typeface="Calibri Light" panose="020F0302020204030204"/>
         <a:ea typeface=""/>
         <a:cs typeface=""/>
-        <a:font script="Jpan" typeface="ＭＳ Ｐゴシック"/>
+        <a:font script="Jpan" typeface="游ゴシック Light"/>
         <a:font script="Hang" typeface="맑은 고딕"/>
-        <a:font script="Hans" typeface="宋体"/>
+        <a:font script="Hans" typeface="等线 Light"/>
         <a:font script="Hant" typeface="新細明體"/>
         <a:font script="Arab" typeface="Times New Roman"/>
         <a:font script="Hebr" typeface="Times New Roman"/>
@@ -11743,14 +11658,31 @@
         <a:font script="Viet" typeface="Times New Roman"/>
         <a:font script="Uigh" typeface="Microsoft Uighur"/>
         <a:font script="Geor" typeface="Sylfaen"/>
+        <a:font script="Armn" typeface="Arial"/>
+        <a:font script="Bugi" typeface="Leelawadee UI"/>
+        <a:font script="Bopo" typeface="Microsoft JhengHei"/>
+        <a:font script="Java" typeface="Javanese Text"/>
+        <a:font script="Lisu" typeface="Segoe UI"/>
+        <a:font script="Mymr" typeface="Myanmar Text"/>
+        <a:font script="Nkoo" typeface="Ebrima"/>
+        <a:font script="Olck" typeface="Nirmala UI"/>
+        <a:font script="Osma" typeface="Ebrima"/>
+        <a:font script="Phag" typeface="Phagspa"/>
+        <a:font script="Syrn" typeface="Estrangelo Edessa"/>
+        <a:font script="Syrj" typeface="Estrangelo Edessa"/>
+        <a:font script="Syre" typeface="Estrangelo Edessa"/>
+        <a:font script="Sora" typeface="Nirmala UI"/>
+        <a:font script="Tale" typeface="Microsoft Tai Le"/>
+        <a:font script="Talu" typeface="Microsoft New Tai Lue"/>
+        <a:font script="Tfng" typeface="Ebrima"/>
       </a:majorFont>
       <a:minorFont>
-        <a:latin typeface="Calibri"/>
+        <a:latin typeface="Calibri" panose="020F0502020204030204"/>
         <a:ea typeface=""/>
         <a:cs typeface=""/>
-        <a:font script="Jpan" typeface="ＭＳ Ｐゴシック"/>
+        <a:font script="Jpan" typeface="游ゴシック"/>
         <a:font script="Hang" typeface="맑은 고딕"/>
-        <a:font script="Hans" typeface="宋体"/>
+        <a:font script="Hans" typeface="等线"/>
         <a:font script="Hant" typeface="新細明體"/>
         <a:font script="Arab" typeface="Arial"/>
         <a:font script="Hebr" typeface="Arial"/>
@@ -11778,6 +11710,23 @@
         <a:font script="Viet" typeface="Arial"/>
         <a:font script="Uigh" typeface="Microsoft Uighur"/>
         <a:font script="Geor" typeface="Sylfaen"/>
+        <a:font script="Armn" typeface="Arial"/>
+        <a:font script="Bugi" typeface="Leelawadee UI"/>
+        <a:font script="Bopo" typeface="Microsoft JhengHei"/>
+        <a:font script="Java" typeface="Javanese Text"/>
+        <a:font script="Lisu" typeface="Segoe UI"/>
+        <a:font script="Mymr" typeface="Myanmar Text"/>
+        <a:font script="Nkoo" typeface="Ebrima"/>
+        <a:font script="Olck" typeface="Nirmala UI"/>
+        <a:font script="Osma" typeface="Ebrima"/>
+        <a:font script="Phag" typeface="Phagspa"/>
+        <a:font script="Syrn" typeface="Estrangelo Edessa"/>
+        <a:font script="Syrj" typeface="Estrangelo Edessa"/>
+        <a:font script="Syre" typeface="Estrangelo Edessa"/>
+        <a:font script="Sora" typeface="Nirmala UI"/>
+        <a:font script="Tale" typeface="Microsoft Tai Le"/>
+        <a:font script="Talu" typeface="Microsoft New Tai Lue"/>
+        <a:font script="Tfng" typeface="Ebrima"/>
       </a:minorFont>
     </a:fontScheme>
     <a:fmtScheme name="Office">
@@ -11789,200 +11738,141 @@
           <a:gsLst>
             <a:gs pos="0">
               <a:schemeClr val="phClr">
-                <a:tint val="50000"/>
-                <a:satMod val="300000"/>
+                <a:lumMod val="110000"/>
+                <a:satMod val="105000"/>
+                <a:tint val="67000"/>
               </a:schemeClr>
             </a:gs>
-            <a:gs pos="35000">
+            <a:gs pos="50000">
               <a:schemeClr val="phClr">
-                <a:tint val="37000"/>
-                <a:satMod val="300000"/>
+                <a:lumMod val="105000"/>
+                <a:satMod val="103000"/>
+                <a:tint val="73000"/>
               </a:schemeClr>
             </a:gs>
             <a:gs pos="100000">
               <a:schemeClr val="phClr">
-                <a:tint val="15000"/>
-                <a:satMod val="350000"/>
+                <a:lumMod val="105000"/>
+                <a:satMod val="109000"/>
+                <a:tint val="81000"/>
               </a:schemeClr>
             </a:gs>
           </a:gsLst>
-          <a:lin ang="16200000" scaled="1"/>
+          <a:lin ang="5400000" scaled="0"/>
         </a:gradFill>
         <a:gradFill rotWithShape="1">
           <a:gsLst>
             <a:gs pos="0">
               <a:schemeClr val="phClr">
-                <a:tint val="100000"/>
+                <a:satMod val="103000"/>
+                <a:lumMod val="102000"/>
+                <a:tint val="94000"/>
+              </a:schemeClr>
+            </a:gs>
+            <a:gs pos="50000">
+              <a:schemeClr val="phClr">
+                <a:satMod val="110000"/>
+                <a:lumMod val="100000"/>
                 <a:shade val="100000"/>
-                <a:satMod val="130000"/>
               </a:schemeClr>
             </a:gs>
             <a:gs pos="100000">
               <a:schemeClr val="phClr">
-                <a:tint val="50000"/>
-                <a:shade val="100000"/>
-                <a:satMod val="350000"/>
+                <a:lumMod val="99000"/>
+                <a:satMod val="120000"/>
+                <a:shade val="78000"/>
               </a:schemeClr>
             </a:gs>
           </a:gsLst>
-          <a:lin ang="16200000" scaled="0"/>
+          <a:lin ang="5400000" scaled="0"/>
         </a:gradFill>
       </a:fillStyleLst>
       <a:lnStyleLst>
-        <a:ln w="9525" cap="flat" cmpd="sng" algn="ctr">
-          <a:solidFill>
-            <a:schemeClr val="phClr">
-              <a:shade val="95000"/>
-              <a:satMod val="105000"/>
-            </a:schemeClr>
-          </a:solidFill>
-          <a:prstDash val="solid"/>
-        </a:ln>
-        <a:ln w="25400" cap="flat" cmpd="sng" algn="ctr">
+        <a:ln w="6350" cap="flat" cmpd="sng" algn="ctr">
           <a:solidFill>
             <a:schemeClr val="phClr"/>
           </a:solidFill>
           <a:prstDash val="solid"/>
+          <a:miter lim="800000"/>
         </a:ln>
-        <a:ln w="38100" cap="flat" cmpd="sng" algn="ctr">
+        <a:ln w="12700" cap="flat" cmpd="sng" algn="ctr">
           <a:solidFill>
             <a:schemeClr val="phClr"/>
           </a:solidFill>
           <a:prstDash val="solid"/>
+          <a:miter lim="800000"/>
+        </a:ln>
+        <a:ln w="19050" cap="flat" cmpd="sng" algn="ctr">
+          <a:solidFill>
+            <a:schemeClr val="phClr"/>
+          </a:solidFill>
+          <a:prstDash val="solid"/>
+          <a:miter lim="800000"/>
         </a:ln>
       </a:lnStyleLst>
       <a:effectStyleLst>
         <a:effectStyle>
+          <a:effectLst/>
+        </a:effectStyle>
+        <a:effectStyle>
+          <a:effectLst/>
+        </a:effectStyle>
+        <a:effectStyle>
           <a:effectLst>
-            <a:outerShdw blurRad="40000" dist="20000" dir="5400000" rotWithShape="0">
+            <a:outerShdw blurRad="57150" dist="19050" dir="5400000" algn="ctr" rotWithShape="0">
               <a:srgbClr val="000000">
-                <a:alpha val="38000"/>
+                <a:alpha val="63000"/>
               </a:srgbClr>
             </a:outerShdw>
           </a:effectLst>
-        </a:effectStyle>
-        <a:effectStyle>
-          <a:effectLst>
-            <a:outerShdw blurRad="40000" dist="23000" dir="5400000" rotWithShape="0">
-              <a:srgbClr val="000000">
-                <a:alpha val="35000"/>
-              </a:srgbClr>
-            </a:outerShdw>
-          </a:effectLst>
-        </a:effectStyle>
-        <a:effectStyle>
-          <a:effectLst>
-            <a:outerShdw blurRad="40000" dist="23000" dir="5400000" rotWithShape="0">
-              <a:srgbClr val="000000">
-                <a:alpha val="35000"/>
-              </a:srgbClr>
-            </a:outerShdw>
-          </a:effectLst>
-          <a:scene3d>
-            <a:camera prst="orthographicFront">
-              <a:rot lat="0" lon="0" rev="0"/>
-            </a:camera>
-            <a:lightRig rig="threePt" dir="t">
-              <a:rot lat="0" lon="0" rev="1200000"/>
-            </a:lightRig>
-          </a:scene3d>
-          <a:sp3d>
-            <a:bevelT w="63500" h="25400"/>
-          </a:sp3d>
         </a:effectStyle>
       </a:effectStyleLst>
       <a:bgFillStyleLst>
         <a:solidFill>
           <a:schemeClr val="phClr"/>
         </a:solidFill>
+        <a:solidFill>
+          <a:schemeClr val="phClr">
+            <a:tint val="95000"/>
+            <a:satMod val="170000"/>
+          </a:schemeClr>
+        </a:solidFill>
         <a:gradFill rotWithShape="1">
           <a:gsLst>
             <a:gs pos="0">
               <a:schemeClr val="phClr">
-                <a:tint val="40000"/>
-                <a:satMod val="350000"/>
+                <a:tint val="93000"/>
+                <a:satMod val="150000"/>
+                <a:shade val="98000"/>
+                <a:lumMod val="102000"/>
               </a:schemeClr>
             </a:gs>
-            <a:gs pos="40000">
+            <a:gs pos="50000">
               <a:schemeClr val="phClr">
-                <a:tint val="45000"/>
-                <a:shade val="99000"/>
-                <a:satMod val="350000"/>
+                <a:tint val="98000"/>
+                <a:satMod val="130000"/>
+                <a:shade val="90000"/>
+                <a:lumMod val="103000"/>
               </a:schemeClr>
             </a:gs>
             <a:gs pos="100000">
               <a:schemeClr val="phClr">
-                <a:shade val="20000"/>
-                <a:satMod val="255000"/>
+                <a:shade val="63000"/>
+                <a:satMod val="120000"/>
               </a:schemeClr>
             </a:gs>
           </a:gsLst>
-          <a:path path="circle">
-            <a:fillToRect l="50000" t="-80000" r="50000" b="180000"/>
-          </a:path>
-        </a:gradFill>
-        <a:gradFill rotWithShape="1">
-          <a:gsLst>
-            <a:gs pos="0">
-              <a:schemeClr val="phClr">
-                <a:tint val="80000"/>
-                <a:satMod val="300000"/>
-              </a:schemeClr>
-            </a:gs>
-            <a:gs pos="100000">
-              <a:schemeClr val="phClr">
-                <a:shade val="30000"/>
-                <a:satMod val="200000"/>
-              </a:schemeClr>
-            </a:gs>
-          </a:gsLst>
-          <a:path path="circle">
-            <a:fillToRect l="50000" t="50000" r="50000" b="50000"/>
-          </a:path>
+          <a:lin ang="5400000" scaled="0"/>
         </a:gradFill>
       </a:bgFillStyleLst>
     </a:fmtScheme>
   </a:themeElements>
-  <a:objectDefaults>
-    <a:spDef>
-      <a:spPr/>
-      <a:bodyPr/>
-      <a:lstStyle/>
-      <a:style>
-        <a:lnRef idx="1">
-          <a:schemeClr val="accent1"/>
-        </a:lnRef>
-        <a:fillRef idx="3">
-          <a:schemeClr val="accent1"/>
-        </a:fillRef>
-        <a:effectRef idx="2">
-          <a:schemeClr val="accent1"/>
-        </a:effectRef>
-        <a:fontRef idx="minor">
-          <a:schemeClr val="lt1"/>
-        </a:fontRef>
-      </a:style>
-    </a:spDef>
-    <a:lnDef>
-      <a:spPr/>
-      <a:bodyPr/>
-      <a:lstStyle/>
-      <a:style>
-        <a:lnRef idx="2">
-          <a:schemeClr val="accent1"/>
-        </a:lnRef>
-        <a:fillRef idx="0">
-          <a:schemeClr val="accent1"/>
-        </a:fillRef>
-        <a:effectRef idx="1">
-          <a:schemeClr val="accent1"/>
-        </a:effectRef>
-        <a:fontRef idx="minor">
-          <a:schemeClr val="tx1"/>
-        </a:fontRef>
-      </a:style>
-    </a:lnDef>
-  </a:objectDefaults>
+  <a:objectDefaults/>
   <a:extraClrSchemeLst/>
+  <a:extLst>
+    <a:ext uri="{05A4C25C-085E-4340-85A3-A5531E510DB2}">
+      <thm15:themeFamily xmlns:thm15="http://schemas.microsoft.com/office/thememl/2012/main" name="Office Theme" id="{62F939B6-93AF-4DB8-9C6B-D6C7DFDC589F}" vid="{4A3C46E8-61CC-4603-A589-7422A47A8E4A}"/>
+    </a:ext>
+  </a:extLst>
 </a:theme>
 </file>
</xml_diff>